<commit_message>
Fallback su Groq (Qwen), dashboard migliorata, suite di test
- Fallback aggiornato a qwen/qwen3.8-27b (reasoning_format=hidden) dopo
  test comparativi diretti: gpt-oss-120b corrompe nomi propri multi-parola
  negli argomenti dei tool, groq/compound non supporta il tool calling
- Timeout per chiamata (30s) per evitare che i retry blocchino l'intero
  event loop durante un'indisponibilita' prolungata di Gemini
- Dashboard: 3 istogrammi token + 3 istogrammi valutazioni (uno per
  combinazione di agenti), fuso orario locale, filtri per agenti/modello
- Nuova cartella testing/ con 43 domande di test categorizzate (CSV + MD)
  e script per eseguirle in serie
- Colonna fallback_usato nel query log per tracciare quando scatta Groq
</commit_message>
<xml_diff>
--- a/Presentazione/Progetto_AgenticAI.pptx
+++ b/Presentazione/Progetto_AgenticAI.pptx
@@ -5,7 +5,7 @@
     <p:sldMasterId id="2147483648" r:id="rId1"/>
   </p:sldMasterIdLst>
   <p:notesMasterIdLst>
-    <p:notesMasterId r:id="rId15"/>
+    <p:notesMasterId r:id="rId18"/>
   </p:notesMasterIdLst>
   <p:sldIdLst>
     <p:sldId id="256" r:id="rId2"/>
@@ -19,8 +19,11 @@
     <p:sldId id="265" r:id="rId10"/>
     <p:sldId id="266" r:id="rId11"/>
     <p:sldId id="269" r:id="rId12"/>
-    <p:sldId id="270" r:id="rId13"/>
-    <p:sldId id="272" r:id="rId14"/>
+    <p:sldId id="275" r:id="rId13"/>
+    <p:sldId id="276" r:id="rId14"/>
+    <p:sldId id="277" r:id="rId15"/>
+    <p:sldId id="272" r:id="rId16"/>
+    <p:sldId id="273" r:id="rId17"/>
   </p:sldIdLst>
   <p:sldSz cx="12192000" cy="6858000"/>
   <p:notesSz cx="6858000" cy="9144000"/>
@@ -209,7 +212,7 @@
           <a:p>
             <a:fld id="{98B0AFFC-1C04-8448-8B8B-8571426B3284}" type="datetimeFigureOut">
               <a:rPr lang="it-IT" smtClean="0"/>
-              <a:t>30/08/26</a:t>
+              <a:t>04/09/26</a:t>
             </a:fld>
             <a:endParaRPr lang="it-IT"/>
           </a:p>
@@ -476,6 +479,97 @@
 </p:notesMaster>
 </file>
 
+<file path=ppt/notesSlides/notesSlide1.xml><?xml version="1.0" encoding="utf-8"?>
+<p:notes xmlns:a="http://schemas.openxmlformats.org/drawingml/2006/main" xmlns:r="http://schemas.openxmlformats.org/officeDocument/2006/relationships" xmlns:p="http://schemas.openxmlformats.org/presentationml/2006/main">
+  <p:cSld>
+    <p:spTree>
+      <p:nvGrpSpPr>
+        <p:cNvPr id="1" name=""/>
+        <p:cNvGrpSpPr/>
+        <p:nvPr/>
+      </p:nvGrpSpPr>
+      <p:grpSpPr>
+        <a:xfrm>
+          <a:off x="0" y="0"/>
+          <a:ext cx="0" cy="0"/>
+          <a:chOff x="0" y="0"/>
+          <a:chExt cx="0" cy="0"/>
+        </a:xfrm>
+      </p:grpSpPr>
+      <p:sp>
+        <p:nvSpPr>
+          <p:cNvPr id="2" name="Segnaposto immagine diapositiva 1"/>
+          <p:cNvSpPr>
+            <a:spLocks noGrp="1" noRot="1" noChangeAspect="1"/>
+          </p:cNvSpPr>
+          <p:nvPr>
+            <p:ph type="sldImg"/>
+          </p:nvPr>
+        </p:nvSpPr>
+        <p:spPr/>
+        <p:txBody>
+          <a:bodyPr/>
+          <a:lstStyle/>
+          <a:p>
+            <a:endParaRPr lang="it-IT"/>
+          </a:p>
+        </p:txBody>
+      </p:sp>
+      <p:sp>
+        <p:nvSpPr>
+          <p:cNvPr id="3" name="Segnaposto note 2"/>
+          <p:cNvSpPr>
+            <a:spLocks noGrp="1"/>
+          </p:cNvSpPr>
+          <p:nvPr>
+            <p:ph type="body" idx="1"/>
+          </p:nvPr>
+        </p:nvSpPr>
+        <p:spPr/>
+        <p:txBody>
+          <a:bodyPr/>
+          <a:lstStyle/>
+          <a:p>
+            <a:endParaRPr lang="it-IT" dirty="0"/>
+          </a:p>
+        </p:txBody>
+      </p:sp>
+      <p:sp>
+        <p:nvSpPr>
+          <p:cNvPr id="4" name="Segnaposto numero diapositiva 3"/>
+          <p:cNvSpPr>
+            <a:spLocks noGrp="1"/>
+          </p:cNvSpPr>
+          <p:nvPr>
+            <p:ph type="sldNum" sz="quarter" idx="5"/>
+          </p:nvPr>
+        </p:nvSpPr>
+        <p:spPr/>
+        <p:txBody>
+          <a:bodyPr/>
+          <a:lstStyle/>
+          <a:p>
+            <a:fld id="{EAB945CC-4EEA-C14F-A9B0-6C62D67CB6F7}" type="slidenum">
+              <a:rPr lang="it-IT" smtClean="0"/>
+              <a:t>10</a:t>
+            </a:fld>
+            <a:endParaRPr lang="it-IT"/>
+          </a:p>
+        </p:txBody>
+      </p:sp>
+    </p:spTree>
+    <p:extLst>
+      <p:ext uri="{BB962C8B-B14F-4D97-AF65-F5344CB8AC3E}">
+        <p14:creationId xmlns:p14="http://schemas.microsoft.com/office/powerpoint/2010/main" val="2942744665"/>
+      </p:ext>
+    </p:extLst>
+  </p:cSld>
+  <p:clrMapOvr>
+    <a:masterClrMapping/>
+  </p:clrMapOvr>
+</p:notes>
+</file>
+
 <file path=ppt/slideLayouts/slideLayout1.xml><?xml version="1.0" encoding="utf-8"?>
 <p:sldLayout xmlns:a="http://schemas.openxmlformats.org/drawingml/2006/main" xmlns:r="http://schemas.openxmlformats.org/officeDocument/2006/relationships" xmlns:p="http://schemas.openxmlformats.org/presentationml/2006/main" type="title" preserve="1">
   <p:cSld name="Diapositiva titolo">
@@ -623,7 +717,7 @@
           <a:p>
             <a:fld id="{BC3B7F7A-EFB6-EE4B-B48E-5A8531EFB82F}" type="datetimeFigureOut">
               <a:rPr lang="it-IT" smtClean="0"/>
-              <a:t>30/08/26</a:t>
+              <a:t>04/09/26</a:t>
             </a:fld>
             <a:endParaRPr lang="it-IT"/>
           </a:p>
@@ -821,7 +915,7 @@
           <a:p>
             <a:fld id="{BC3B7F7A-EFB6-EE4B-B48E-5A8531EFB82F}" type="datetimeFigureOut">
               <a:rPr lang="it-IT" smtClean="0"/>
-              <a:t>30/08/26</a:t>
+              <a:t>04/09/26</a:t>
             </a:fld>
             <a:endParaRPr lang="it-IT"/>
           </a:p>
@@ -1029,7 +1123,7 @@
           <a:p>
             <a:fld id="{BC3B7F7A-EFB6-EE4B-B48E-5A8531EFB82F}" type="datetimeFigureOut">
               <a:rPr lang="it-IT" smtClean="0"/>
-              <a:t>30/08/26</a:t>
+              <a:t>04/09/26</a:t>
             </a:fld>
             <a:endParaRPr lang="it-IT"/>
           </a:p>
@@ -1227,7 +1321,7 @@
           <a:p>
             <a:fld id="{BC3B7F7A-EFB6-EE4B-B48E-5A8531EFB82F}" type="datetimeFigureOut">
               <a:rPr lang="it-IT" smtClean="0"/>
-              <a:t>30/08/26</a:t>
+              <a:t>04/09/26</a:t>
             </a:fld>
             <a:endParaRPr lang="it-IT"/>
           </a:p>
@@ -1502,7 +1596,7 @@
           <a:p>
             <a:fld id="{BC3B7F7A-EFB6-EE4B-B48E-5A8531EFB82F}" type="datetimeFigureOut">
               <a:rPr lang="it-IT" smtClean="0"/>
-              <a:t>30/08/26</a:t>
+              <a:t>04/09/26</a:t>
             </a:fld>
             <a:endParaRPr lang="it-IT"/>
           </a:p>
@@ -1767,7 +1861,7 @@
           <a:p>
             <a:fld id="{BC3B7F7A-EFB6-EE4B-B48E-5A8531EFB82F}" type="datetimeFigureOut">
               <a:rPr lang="it-IT" smtClean="0"/>
-              <a:t>30/08/26</a:t>
+              <a:t>04/09/26</a:t>
             </a:fld>
             <a:endParaRPr lang="it-IT"/>
           </a:p>
@@ -2179,7 +2273,7 @@
           <a:p>
             <a:fld id="{BC3B7F7A-EFB6-EE4B-B48E-5A8531EFB82F}" type="datetimeFigureOut">
               <a:rPr lang="it-IT" smtClean="0"/>
-              <a:t>30/08/26</a:t>
+              <a:t>04/09/26</a:t>
             </a:fld>
             <a:endParaRPr lang="it-IT"/>
           </a:p>
@@ -2320,7 +2414,7 @@
           <a:p>
             <a:fld id="{BC3B7F7A-EFB6-EE4B-B48E-5A8531EFB82F}" type="datetimeFigureOut">
               <a:rPr lang="it-IT" smtClean="0"/>
-              <a:t>30/08/26</a:t>
+              <a:t>04/09/26</a:t>
             </a:fld>
             <a:endParaRPr lang="it-IT"/>
           </a:p>
@@ -2433,7 +2527,7 @@
           <a:p>
             <a:fld id="{BC3B7F7A-EFB6-EE4B-B48E-5A8531EFB82F}" type="datetimeFigureOut">
               <a:rPr lang="it-IT" smtClean="0"/>
-              <a:t>30/08/26</a:t>
+              <a:t>04/09/26</a:t>
             </a:fld>
             <a:endParaRPr lang="it-IT"/>
           </a:p>
@@ -2744,7 +2838,7 @@
           <a:p>
             <a:fld id="{BC3B7F7A-EFB6-EE4B-B48E-5A8531EFB82F}" type="datetimeFigureOut">
               <a:rPr lang="it-IT" smtClean="0"/>
-              <a:t>30/08/26</a:t>
+              <a:t>04/09/26</a:t>
             </a:fld>
             <a:endParaRPr lang="it-IT"/>
           </a:p>
@@ -3032,7 +3126,7 @@
           <a:p>
             <a:fld id="{BC3B7F7A-EFB6-EE4B-B48E-5A8531EFB82F}" type="datetimeFigureOut">
               <a:rPr lang="it-IT" smtClean="0"/>
-              <a:t>30/08/26</a:t>
+              <a:t>04/09/26</a:t>
             </a:fld>
             <a:endParaRPr lang="it-IT"/>
           </a:p>
@@ -3273,7 +3367,7 @@
           <a:p>
             <a:fld id="{BC3B7F7A-EFB6-EE4B-B48E-5A8531EFB82F}" type="datetimeFigureOut">
               <a:rPr lang="it-IT" smtClean="0"/>
-              <a:t>30/08/26</a:t>
+              <a:t>04/09/26</a:t>
             </a:fld>
             <a:endParaRPr lang="it-IT"/>
           </a:p>
@@ -3708,10 +3802,15 @@
         </p:nvSpPr>
         <p:spPr/>
         <p:txBody>
-          <a:bodyPr/>
+          <a:bodyPr>
+            <a:normAutofit/>
+          </a:bodyPr>
           <a:lstStyle/>
           <a:p>
-            <a:endParaRPr lang="it-IT"/>
+            <a:r>
+              <a:rPr lang="it-IT" sz="4800" dirty="0"/>
+              <a:t>Cinema Graph RAG Creative Agent</a:t>
+            </a:r>
           </a:p>
         </p:txBody>
       </p:sp>
@@ -3736,7 +3835,16 @@
           <a:bodyPr/>
           <a:lstStyle/>
           <a:p>
-            <a:endParaRPr lang="it-IT"/>
+            <a:r>
+              <a:rPr lang="it-IT" dirty="0"/>
+              <a:t>Progetto di Programmazione di Applicazioni Intelligenti</a:t>
+            </a:r>
+          </a:p>
+          <a:p>
+            <a:r>
+              <a:rPr lang="it-IT" dirty="0"/>
+              <a:t>20038873 Marone Aunet Pier Gabriel</a:t>
+            </a:r>
           </a:p>
         </p:txBody>
       </p:sp>
@@ -3800,26 +3908,727 @@
       </p:sp>
       <p:sp>
         <p:nvSpPr>
-          <p:cNvPr id="3" name="Segnaposto contenuto 2">
-            <a:extLst>
-              <a:ext uri="{FF2B5EF4-FFF2-40B4-BE49-F238E27FC236}">
-                <a16:creationId xmlns:a16="http://schemas.microsoft.com/office/drawing/2014/main" id="{DEB06041-47E5-0165-C9BF-7BF8E765A7D6}"/>
+          <p:cNvPr id="5" name="CasellaDiTesto 4">
+            <a:extLst>
+              <a:ext uri="{FF2B5EF4-FFF2-40B4-BE49-F238E27FC236}">
+                <a16:creationId xmlns:a16="http://schemas.microsoft.com/office/drawing/2014/main" id="{EB20F9C4-2B19-558E-2D8C-A85F4345E32C}"/>
+              </a:ext>
+            </a:extLst>
+          </p:cNvPr>
+          <p:cNvSpPr txBox="1"/>
+          <p:nvPr/>
+        </p:nvSpPr>
+        <p:spPr>
+          <a:xfrm>
+            <a:off x="544606" y="1690688"/>
+            <a:ext cx="11102788" cy="646331"/>
+          </a:xfrm>
+          <a:prstGeom prst="rect">
+            <a:avLst/>
+          </a:prstGeom>
+          <a:noFill/>
+          <a:ln>
+            <a:solidFill>
+              <a:schemeClr val="tx1"/>
+            </a:solidFill>
+          </a:ln>
+        </p:spPr>
+        <p:txBody>
+          <a:bodyPr wrap="square">
+            <a:spAutoFit/>
+          </a:bodyPr>
+          <a:lstStyle/>
+          <a:p>
+            <a:r>
+              <a:rPr lang="it-IT" b="0" i="0" u="none" strike="noStrike" dirty="0">
+                <a:effectLst/>
+              </a:rPr>
+              <a:t>Genera un pitch creativo per un nuovo film fondendo le atmosfere di Interstellar e The Dark Knight, con un cast reale scelto tra i collaboratori abituali di Christopher Nolan, motivato dai dati delle loro collaborazioni passate.</a:t>
+            </a:r>
+            <a:endParaRPr lang="it-IT" dirty="0"/>
+          </a:p>
+        </p:txBody>
+      </p:sp>
+      <p:sp>
+        <p:nvSpPr>
+          <p:cNvPr id="6" name="CasellaDiTesto 5">
+            <a:extLst>
+              <a:ext uri="{FF2B5EF4-FFF2-40B4-BE49-F238E27FC236}">
+                <a16:creationId xmlns:a16="http://schemas.microsoft.com/office/drawing/2014/main" id="{7DE54C63-9F21-5352-C625-3D18268BD96F}"/>
+              </a:ext>
+            </a:extLst>
+          </p:cNvPr>
+          <p:cNvSpPr txBox="1"/>
+          <p:nvPr/>
+        </p:nvSpPr>
+        <p:spPr>
+          <a:xfrm>
+            <a:off x="544606" y="1387393"/>
+            <a:ext cx="1065933" cy="307777"/>
+          </a:xfrm>
+          <a:prstGeom prst="rect">
+            <a:avLst/>
+          </a:prstGeom>
+          <a:noFill/>
+        </p:spPr>
+        <p:txBody>
+          <a:bodyPr wrap="none" rtlCol="0">
+            <a:spAutoFit/>
+          </a:bodyPr>
+          <a:lstStyle/>
+          <a:p>
+            <a:r>
+              <a:rPr lang="it-IT" sz="1400" b="1" dirty="0"/>
+              <a:t>DOMANDA</a:t>
+            </a:r>
+          </a:p>
+        </p:txBody>
+      </p:sp>
+      <p:sp>
+        <p:nvSpPr>
+          <p:cNvPr id="7" name="CasellaDiTesto 6">
+            <a:extLst>
+              <a:ext uri="{FF2B5EF4-FFF2-40B4-BE49-F238E27FC236}">
+                <a16:creationId xmlns:a16="http://schemas.microsoft.com/office/drawing/2014/main" id="{F4E27C52-2712-5724-75D5-7A0D5CB8716A}"/>
+              </a:ext>
+            </a:extLst>
+          </p:cNvPr>
+          <p:cNvSpPr txBox="1"/>
+          <p:nvPr/>
+        </p:nvSpPr>
+        <p:spPr>
+          <a:xfrm>
+            <a:off x="544606" y="2559067"/>
+            <a:ext cx="998607" cy="307777"/>
+          </a:xfrm>
+          <a:prstGeom prst="rect">
+            <a:avLst/>
+          </a:prstGeom>
+          <a:noFill/>
+        </p:spPr>
+        <p:txBody>
+          <a:bodyPr wrap="none" rtlCol="0">
+            <a:spAutoFit/>
+          </a:bodyPr>
+          <a:lstStyle/>
+          <a:p>
+            <a:r>
+              <a:rPr lang="it-IT" sz="1400" b="1" dirty="0"/>
+              <a:t>RISPOSTA</a:t>
+            </a:r>
+          </a:p>
+        </p:txBody>
+      </p:sp>
+      <p:sp>
+        <p:nvSpPr>
+          <p:cNvPr id="8" name="Rectangle 1">
+            <a:extLst>
+              <a:ext uri="{FF2B5EF4-FFF2-40B4-BE49-F238E27FC236}">
+                <a16:creationId xmlns:a16="http://schemas.microsoft.com/office/drawing/2014/main" id="{243AA421-5F79-A0C2-2947-09DD3F6C147D}"/>
               </a:ext>
             </a:extLst>
           </p:cNvPr>
           <p:cNvSpPr>
-            <a:spLocks noGrp="1"/>
+            <a:spLocks noChangeArrowheads="1"/>
           </p:cNvSpPr>
-          <p:nvPr>
-            <p:ph idx="1"/>
-          </p:nvPr>
-        </p:nvSpPr>
-        <p:spPr/>
-        <p:txBody>
-          <a:bodyPr/>
-          <a:lstStyle/>
-          <a:p>
-            <a:endParaRPr lang="it-IT"/>
+          <p:nvPr/>
+        </p:nvSpPr>
+        <p:spPr bwMode="auto">
+          <a:xfrm>
+            <a:off x="544606" y="2866844"/>
+            <a:ext cx="11102788" cy="3877985"/>
+          </a:xfrm>
+          <a:prstGeom prst="rect">
+            <a:avLst/>
+          </a:prstGeom>
+          <a:noFill/>
+          <a:ln w="9525">
+            <a:solidFill>
+              <a:schemeClr val="tx1"/>
+            </a:solidFill>
+            <a:miter lim="800000"/>
+            <a:headEnd/>
+            <a:tailEnd/>
+          </a:ln>
+          <a:effectLst/>
+          <a:extLst>
+            <a:ext uri="{909E8E84-426E-40DD-AFC4-6F175D3DCCD1}">
+              <a14:hiddenFill xmlns:a14="http://schemas.microsoft.com/office/drawing/2010/main">
+                <a:solidFill>
+                  <a:schemeClr val="accent1"/>
+                </a:solidFill>
+              </a14:hiddenFill>
+            </a:ext>
+            <a:ext uri="{AF507438-7753-43E0-B8FC-AC1667EBCBE1}">
+              <a14:hiddenEffects xmlns:a14="http://schemas.microsoft.com/office/drawing/2010/main">
+                <a:effectLst>
+                  <a:outerShdw dist="35921" dir="2700000" algn="ctr" rotWithShape="0">
+                    <a:schemeClr val="bg2"/>
+                  </a:outerShdw>
+                </a:effectLst>
+              </a14:hiddenEffects>
+            </a:ext>
+          </a:extLst>
+        </p:spPr>
+        <p:txBody>
+          <a:bodyPr vert="horz" wrap="square" lIns="108000" tIns="0" rIns="0" bIns="0" numCol="1" anchor="ctr" anchorCtr="0" compatLnSpc="1">
+            <a:prstTxWarp prst="textNoShape">
+              <a:avLst/>
+            </a:prstTxWarp>
+            <a:spAutoFit/>
+          </a:bodyPr>
+          <a:lstStyle>
+            <a:lvl1pPr eaLnBrk="0" fontAlgn="base" hangingPunct="0">
+              <a:spcBef>
+                <a:spcPct val="0"/>
+              </a:spcBef>
+              <a:spcAft>
+                <a:spcPct val="0"/>
+              </a:spcAft>
+              <a:defRPr>
+                <a:solidFill>
+                  <a:schemeClr val="tx1"/>
+                </a:solidFill>
+                <a:latin typeface="Arial" panose="020B0604020202020204" pitchFamily="34" charset="0"/>
+              </a:defRPr>
+            </a:lvl1pPr>
+            <a:lvl2pPr eaLnBrk="0" fontAlgn="base" hangingPunct="0">
+              <a:spcBef>
+                <a:spcPct val="0"/>
+              </a:spcBef>
+              <a:spcAft>
+                <a:spcPct val="0"/>
+              </a:spcAft>
+              <a:defRPr>
+                <a:solidFill>
+                  <a:schemeClr val="tx1"/>
+                </a:solidFill>
+                <a:latin typeface="Arial" panose="020B0604020202020204" pitchFamily="34" charset="0"/>
+              </a:defRPr>
+            </a:lvl2pPr>
+            <a:lvl3pPr eaLnBrk="0" fontAlgn="base" hangingPunct="0">
+              <a:spcBef>
+                <a:spcPct val="0"/>
+              </a:spcBef>
+              <a:spcAft>
+                <a:spcPct val="0"/>
+              </a:spcAft>
+              <a:defRPr>
+                <a:solidFill>
+                  <a:schemeClr val="tx1"/>
+                </a:solidFill>
+                <a:latin typeface="Arial" panose="020B0604020202020204" pitchFamily="34" charset="0"/>
+              </a:defRPr>
+            </a:lvl3pPr>
+            <a:lvl4pPr eaLnBrk="0" fontAlgn="base" hangingPunct="0">
+              <a:spcBef>
+                <a:spcPct val="0"/>
+              </a:spcBef>
+              <a:spcAft>
+                <a:spcPct val="0"/>
+              </a:spcAft>
+              <a:defRPr>
+                <a:solidFill>
+                  <a:schemeClr val="tx1"/>
+                </a:solidFill>
+                <a:latin typeface="Arial" panose="020B0604020202020204" pitchFamily="34" charset="0"/>
+              </a:defRPr>
+            </a:lvl4pPr>
+            <a:lvl5pPr eaLnBrk="0" fontAlgn="base" hangingPunct="0">
+              <a:spcBef>
+                <a:spcPct val="0"/>
+              </a:spcBef>
+              <a:spcAft>
+                <a:spcPct val="0"/>
+              </a:spcAft>
+              <a:defRPr>
+                <a:solidFill>
+                  <a:schemeClr val="tx1"/>
+                </a:solidFill>
+                <a:latin typeface="Arial" panose="020B0604020202020204" pitchFamily="34" charset="0"/>
+              </a:defRPr>
+            </a:lvl5pPr>
+            <a:lvl6pPr eaLnBrk="0" fontAlgn="base" hangingPunct="0">
+              <a:spcBef>
+                <a:spcPct val="0"/>
+              </a:spcBef>
+              <a:spcAft>
+                <a:spcPct val="0"/>
+              </a:spcAft>
+              <a:defRPr>
+                <a:solidFill>
+                  <a:schemeClr val="tx1"/>
+                </a:solidFill>
+                <a:latin typeface="Arial" panose="020B0604020202020204" pitchFamily="34" charset="0"/>
+              </a:defRPr>
+            </a:lvl6pPr>
+            <a:lvl7pPr eaLnBrk="0" fontAlgn="base" hangingPunct="0">
+              <a:spcBef>
+                <a:spcPct val="0"/>
+              </a:spcBef>
+              <a:spcAft>
+                <a:spcPct val="0"/>
+              </a:spcAft>
+              <a:defRPr>
+                <a:solidFill>
+                  <a:schemeClr val="tx1"/>
+                </a:solidFill>
+                <a:latin typeface="Arial" panose="020B0604020202020204" pitchFamily="34" charset="0"/>
+              </a:defRPr>
+            </a:lvl7pPr>
+            <a:lvl8pPr eaLnBrk="0" fontAlgn="base" hangingPunct="0">
+              <a:spcBef>
+                <a:spcPct val="0"/>
+              </a:spcBef>
+              <a:spcAft>
+                <a:spcPct val="0"/>
+              </a:spcAft>
+              <a:defRPr>
+                <a:solidFill>
+                  <a:schemeClr val="tx1"/>
+                </a:solidFill>
+                <a:latin typeface="Arial" panose="020B0604020202020204" pitchFamily="34" charset="0"/>
+              </a:defRPr>
+            </a:lvl8pPr>
+            <a:lvl9pPr eaLnBrk="0" fontAlgn="base" hangingPunct="0">
+              <a:spcBef>
+                <a:spcPct val="0"/>
+              </a:spcBef>
+              <a:spcAft>
+                <a:spcPct val="0"/>
+              </a:spcAft>
+              <a:defRPr>
+                <a:solidFill>
+                  <a:schemeClr val="tx1"/>
+                </a:solidFill>
+                <a:latin typeface="Arial" panose="020B0604020202020204" pitchFamily="34" charset="0"/>
+              </a:defRPr>
+            </a:lvl9pPr>
+          </a:lstStyle>
+          <a:p>
+            <a:pPr marL="0" marR="0" lvl="0" indent="0" algn="l" defTabSz="914400" rtl="0" eaLnBrk="0" fontAlgn="base" latinLnBrk="0" hangingPunct="0">
+              <a:lnSpc>
+                <a:spcPct val="100000"/>
+              </a:lnSpc>
+              <a:spcBef>
+                <a:spcPct val="0"/>
+              </a:spcBef>
+              <a:spcAft>
+                <a:spcPct val="0"/>
+              </a:spcAft>
+              <a:buClrTx/>
+              <a:buSzTx/>
+              <a:buFontTx/>
+              <a:buNone/>
+              <a:tabLst/>
+            </a:pPr>
+            <a:r>
+              <a:rPr kumimoji="0" lang="it-IT" altLang="it-IT" sz="1400" b="1" i="0" u="none" strike="noStrike" cap="none" normalizeH="0" baseline="0" dirty="0">
+                <a:ln>
+                  <a:noFill/>
+                </a:ln>
+                <a:effectLst/>
+                <a:latin typeface="+mn-lt"/>
+              </a:rPr>
+              <a:t>TITOLO DEL PITCH: </a:t>
+            </a:r>
+            <a:r>
+              <a:rPr kumimoji="0" lang="it-IT" altLang="it-IT" sz="1400" b="1" i="1" u="none" strike="noStrike" cap="none" normalizeH="0" baseline="0" dirty="0">
+                <a:ln>
+                  <a:noFill/>
+                </a:ln>
+                <a:effectLst/>
+                <a:latin typeface="+mn-lt"/>
+              </a:rPr>
+              <a:t>THE DARK HORIZON</a:t>
+            </a:r>
+            <a:endParaRPr kumimoji="0" lang="it-IT" altLang="it-IT" sz="1400" b="1" i="0" u="none" strike="noStrike" cap="none" normalizeH="0" baseline="0" dirty="0">
+              <a:ln>
+                <a:noFill/>
+              </a:ln>
+              <a:effectLst/>
+              <a:latin typeface="+mn-lt"/>
+            </a:endParaRPr>
+          </a:p>
+          <a:p>
+            <a:pPr marL="0" marR="0" lvl="0" indent="0" algn="l" defTabSz="914400" rtl="0" eaLnBrk="0" fontAlgn="base" latinLnBrk="0" hangingPunct="0">
+              <a:lnSpc>
+                <a:spcPct val="100000"/>
+              </a:lnSpc>
+              <a:spcBef>
+                <a:spcPct val="0"/>
+              </a:spcBef>
+              <a:spcAft>
+                <a:spcPct val="0"/>
+              </a:spcAft>
+              <a:buClrTx/>
+              <a:buSzTx/>
+              <a:buFontTx/>
+              <a:buNone/>
+              <a:tabLst/>
+            </a:pPr>
+            <a:r>
+              <a:rPr kumimoji="0" lang="it-IT" altLang="it-IT" sz="1400" b="1" i="0" u="none" strike="noStrike" cap="none" normalizeH="0" baseline="0" dirty="0">
+                <a:ln>
+                  <a:noFill/>
+                </a:ln>
+                <a:effectLst/>
+                <a:latin typeface="+mn-lt"/>
+              </a:rPr>
+              <a:t>Il Concept</a:t>
+            </a:r>
+          </a:p>
+          <a:p>
+            <a:pPr marL="0" marR="0" lvl="0" indent="0" algn="l" defTabSz="914400" rtl="0" eaLnBrk="0" fontAlgn="base" latinLnBrk="0" hangingPunct="0">
+              <a:lnSpc>
+                <a:spcPct val="100000"/>
+              </a:lnSpc>
+              <a:spcBef>
+                <a:spcPct val="0"/>
+              </a:spcBef>
+              <a:spcAft>
+                <a:spcPct val="0"/>
+              </a:spcAft>
+              <a:buClrTx/>
+              <a:buSzTx/>
+              <a:buFontTx/>
+              <a:buNone/>
+              <a:tabLst/>
+            </a:pPr>
+            <a:r>
+              <a:rPr kumimoji="0" lang="it-IT" altLang="it-IT" sz="1400" b="0" i="0" u="none" strike="noStrike" cap="none" normalizeH="0" baseline="0" dirty="0">
+                <a:ln>
+                  <a:noFill/>
+                </a:ln>
+                <a:effectLst/>
+                <a:latin typeface="+mn-lt"/>
+              </a:rPr>
+              <a:t>Gotham City sta collassando non solo sotto il peso della criminalità, ma a causa del </a:t>
+            </a:r>
+            <a:r>
+              <a:rPr kumimoji="0" lang="it-IT" altLang="it-IT" sz="1400" b="0" i="1" u="none" strike="noStrike" cap="none" normalizeH="0" baseline="0" dirty="0">
+                <a:ln>
+                  <a:noFill/>
+                </a:ln>
+                <a:effectLst/>
+                <a:latin typeface="+mn-lt"/>
+              </a:rPr>
+              <a:t>blight</a:t>
+            </a:r>
+            <a:r>
+              <a:rPr kumimoji="0" lang="it-IT" altLang="it-IT" sz="1400" b="0" i="0" u="none" strike="noStrike" cap="none" normalizeH="0" baseline="0" dirty="0">
+                <a:ln>
+                  <a:noFill/>
+                </a:ln>
+                <a:effectLst/>
+                <a:latin typeface="+mn-lt"/>
+              </a:rPr>
+              <a:t>, la piaga globale che sta consumando l'ossigeno della Terra. Mentre il </a:t>
+            </a:r>
+            <a:r>
+              <a:rPr kumimoji="0" lang="it-IT" altLang="it-IT" sz="1400" b="1" i="0" u="none" strike="noStrike" cap="none" normalizeH="0" baseline="0" dirty="0">
+                <a:ln>
+                  <a:noFill/>
+                </a:ln>
+                <a:effectLst/>
+                <a:latin typeface="+mn-lt"/>
+              </a:rPr>
+              <a:t>Joker</a:t>
+            </a:r>
+            <a:r>
+              <a:rPr kumimoji="0" lang="it-IT" altLang="it-IT" sz="1400" b="0" i="0" u="none" strike="noStrike" cap="none" normalizeH="0" baseline="0" dirty="0">
+                <a:ln>
+                  <a:noFill/>
+                </a:ln>
+                <a:effectLst/>
+                <a:latin typeface="+mn-lt"/>
+              </a:rPr>
+              <a:t> sfrutta la disperazione collettiva per scatenare un'ondata di nichilismo anarchico, sostenendo che l'estinzione dell'umanità sia inevitabile, il miliardario filantropo e vigilante Bruce Wayne finanzia una missione segreta della NASA per varcare un wormhole interstellare. La giustizia urbana e la sopravvivenza cosmica si fondono: Batman deve scegliere se combattere la sua ultima battaglia tra i grattacieli in rovina di una Gotham morente o sacrificarsi per guidare l'umanità verso una nuova alba tra le stelle.</a:t>
+            </a:r>
+          </a:p>
+          <a:p>
+            <a:pPr marL="0" marR="0" lvl="0" indent="0" algn="l" defTabSz="914400" rtl="0" eaLnBrk="0" fontAlgn="base" latinLnBrk="0" hangingPunct="0">
+              <a:lnSpc>
+                <a:spcPct val="100000"/>
+              </a:lnSpc>
+              <a:spcBef>
+                <a:spcPct val="0"/>
+              </a:spcBef>
+              <a:spcAft>
+                <a:spcPct val="0"/>
+              </a:spcAft>
+              <a:buClrTx/>
+              <a:buSzTx/>
+              <a:buFontTx/>
+              <a:buNone/>
+              <a:tabLst/>
+            </a:pPr>
+            <a:endParaRPr kumimoji="0" lang="it-IT" altLang="it-IT" sz="1400" b="0" i="0" u="none" strike="noStrike" cap="none" normalizeH="0" baseline="0" dirty="0">
+              <a:ln>
+                <a:noFill/>
+              </a:ln>
+              <a:effectLst/>
+              <a:latin typeface="+mn-lt"/>
+            </a:endParaRPr>
+          </a:p>
+          <a:p>
+            <a:pPr lvl="0"/>
+            <a:r>
+              <a:rPr lang="it-IT" altLang="it-IT" sz="1400" b="1" dirty="0">
+                <a:latin typeface="+mn-lt"/>
+              </a:rPr>
+              <a:t>l Casting Giustificato dai Dati</a:t>
+            </a:r>
+          </a:p>
+          <a:p>
+            <a:pPr lvl="0"/>
+            <a:r>
+              <a:rPr lang="it-IT" altLang="it-IT" sz="1400" dirty="0">
+                <a:latin typeface="+mn-lt"/>
+              </a:rPr>
+              <a:t>Il cast è composto interamente da attori legati a doppio filo alla filmografia di Christopher Nolan, garantendo la continuità stilistica e tematica tra il realismo urbano di Gotham e l'epopea sci-fi di </a:t>
+            </a:r>
+            <a:r>
+              <a:rPr lang="it-IT" altLang="it-IT" sz="1400" i="1" dirty="0">
+                <a:latin typeface="+mn-lt"/>
+              </a:rPr>
+              <a:t>Interstellar</a:t>
+            </a:r>
+            <a:r>
+              <a:rPr lang="it-IT" altLang="it-IT" sz="1400" dirty="0">
+                <a:latin typeface="+mn-lt"/>
+              </a:rPr>
+              <a:t>.</a:t>
+            </a:r>
+          </a:p>
+          <a:p>
+            <a:pPr marL="285750" lvl="0" indent="-285750">
+              <a:buFontTx/>
+              <a:buChar char="-"/>
+            </a:pPr>
+            <a:r>
+              <a:rPr lang="it-IT" altLang="it-IT" sz="1400" b="1" dirty="0">
+                <a:latin typeface="+mn-lt"/>
+              </a:rPr>
+              <a:t>Christian Bale</a:t>
+            </a:r>
+            <a:r>
+              <a:rPr lang="it-IT" altLang="it-IT" sz="1400" dirty="0">
+                <a:latin typeface="+mn-lt"/>
+              </a:rPr>
+              <a:t> nel ruolo del protagonista (Bruce Wayne / Batman). L'attore ha collaborato storicamente per </a:t>
+            </a:r>
+            <a:r>
+              <a:rPr lang="it-IT" altLang="it-IT" sz="1400" b="1" dirty="0">
+                <a:latin typeface="+mn-lt"/>
+              </a:rPr>
+              <a:t>4 film</a:t>
+            </a:r>
+            <a:r>
+              <a:rPr lang="it-IT" altLang="it-IT" sz="1400" dirty="0">
+                <a:latin typeface="+mn-lt"/>
+              </a:rPr>
+              <a:t> con Nolan (</a:t>
+            </a:r>
+            <a:r>
+              <a:rPr lang="it-IT" altLang="it-IT" sz="1400" i="1" dirty="0">
+                <a:latin typeface="+mn-lt"/>
+              </a:rPr>
+              <a:t>Batman Begins</a:t>
+            </a:r>
+            <a:r>
+              <a:rPr lang="it-IT" altLang="it-IT" sz="1400" dirty="0">
+                <a:latin typeface="+mn-lt"/>
+              </a:rPr>
+              <a:t>, </a:t>
+            </a:r>
+            <a:r>
+              <a:rPr lang="it-IT" altLang="it-IT" sz="1400" i="1" dirty="0">
+                <a:latin typeface="+mn-lt"/>
+              </a:rPr>
+              <a:t>The Prestige</a:t>
+            </a:r>
+            <a:r>
+              <a:rPr lang="it-IT" altLang="it-IT" sz="1400" dirty="0">
+                <a:latin typeface="+mn-lt"/>
+              </a:rPr>
+              <a:t>, </a:t>
+            </a:r>
+            <a:r>
+              <a:rPr lang="it-IT" altLang="it-IT" sz="1400" i="1" dirty="0">
+                <a:latin typeface="+mn-lt"/>
+              </a:rPr>
+              <a:t>The Dark Knight</a:t>
+            </a:r>
+            <a:r>
+              <a:rPr lang="it-IT" altLang="it-IT" sz="1400" dirty="0">
+                <a:latin typeface="+mn-lt"/>
+              </a:rPr>
+              <a:t>, </a:t>
+            </a:r>
+            <a:r>
+              <a:rPr lang="it-IT" altLang="it-IT" sz="1400" i="1" dirty="0">
+                <a:latin typeface="+mn-lt"/>
+              </a:rPr>
+              <a:t>The Dark Knight Rises</a:t>
+            </a:r>
+            <a:r>
+              <a:rPr lang="it-IT" altLang="it-IT" sz="1400" dirty="0">
+                <a:latin typeface="+mn-lt"/>
+              </a:rPr>
+              <a:t>), incarnando per eccellenza la dualità morale e il tormento del Cavaliere Oscuro.</a:t>
+            </a:r>
+          </a:p>
+          <a:p>
+            <a:pPr marL="285750" lvl="0" indent="-285750">
+              <a:buFontTx/>
+              <a:buChar char="-"/>
+            </a:pPr>
+            <a:r>
+              <a:rPr lang="it-IT" altLang="it-IT" sz="1400" b="1" dirty="0">
+                <a:latin typeface="+mn-lt"/>
+              </a:rPr>
+              <a:t>Anne Hathaway</a:t>
+            </a:r>
+            <a:r>
+              <a:rPr lang="it-IT" altLang="it-IT" sz="1400" dirty="0">
+                <a:latin typeface="+mn-lt"/>
+              </a:rPr>
+              <a:t> nel ruolo di Amelia Brand, la scienziata e astronauta che affianca il protagonista nel viaggio oltre il wormhole. L'attrice vanta </a:t>
+            </a:r>
+            <a:r>
+              <a:rPr lang="it-IT" altLang="it-IT" sz="1400" b="1" dirty="0">
+                <a:latin typeface="+mn-lt"/>
+              </a:rPr>
+              <a:t>2 film</a:t>
+            </a:r>
+            <a:r>
+              <a:rPr lang="it-IT" altLang="it-IT" sz="1400" dirty="0">
+                <a:latin typeface="+mn-lt"/>
+              </a:rPr>
+              <a:t> con il regista (</a:t>
+            </a:r>
+            <a:r>
+              <a:rPr lang="it-IT" altLang="it-IT" sz="1400" i="1" dirty="0">
+                <a:latin typeface="+mn-lt"/>
+              </a:rPr>
+              <a:t>The Dark Knight Rises</a:t>
+            </a:r>
+            <a:r>
+              <a:rPr lang="it-IT" altLang="it-IT" sz="1400" dirty="0">
+                <a:latin typeface="+mn-lt"/>
+              </a:rPr>
+              <a:t> e </a:t>
+            </a:r>
+            <a:r>
+              <a:rPr lang="it-IT" altLang="it-IT" sz="1400" i="1" dirty="0">
+                <a:latin typeface="+mn-lt"/>
+              </a:rPr>
+              <a:t>Interstellar</a:t>
+            </a:r>
+            <a:r>
+              <a:rPr lang="it-IT" altLang="it-IT" sz="1400" dirty="0">
+                <a:latin typeface="+mn-lt"/>
+              </a:rPr>
+              <a:t>), unendo idealmente l'universo di Gotham al viaggio interstellare.</a:t>
+            </a:r>
+          </a:p>
+          <a:p>
+            <a:pPr marL="285750" lvl="0" indent="-285750">
+              <a:buFontTx/>
+              <a:buChar char="-"/>
+            </a:pPr>
+            <a:r>
+              <a:rPr lang="it-IT" altLang="it-IT" sz="1400" b="1" dirty="0">
+                <a:latin typeface="+mn-lt"/>
+              </a:rPr>
+              <a:t>Michael Caine</a:t>
+            </a:r>
+            <a:r>
+              <a:rPr lang="it-IT" altLang="it-IT" sz="1400" dirty="0">
+                <a:latin typeface="+mn-lt"/>
+              </a:rPr>
+              <a:t> nel ruolo del Professor John Brand (mentore scientifico e figura paterna). Pilastro assoluto della filmografia nolaniana con ben </a:t>
+            </a:r>
+            <a:r>
+              <a:rPr lang="it-IT" altLang="it-IT" sz="1400" b="1" dirty="0">
+                <a:latin typeface="+mn-lt"/>
+              </a:rPr>
+              <a:t>5 film</a:t>
+            </a:r>
+            <a:r>
+              <a:rPr lang="it-IT" altLang="it-IT" sz="1400" dirty="0">
+                <a:latin typeface="+mn-lt"/>
+              </a:rPr>
+              <a:t> all'attivo (</a:t>
+            </a:r>
+            <a:r>
+              <a:rPr lang="it-IT" altLang="it-IT" sz="1400" i="1" dirty="0">
+                <a:latin typeface="+mn-lt"/>
+              </a:rPr>
+              <a:t>Batman Begins</a:t>
+            </a:r>
+            <a:r>
+              <a:rPr lang="it-IT" altLang="it-IT" sz="1400" dirty="0">
+                <a:latin typeface="+mn-lt"/>
+              </a:rPr>
+              <a:t>, </a:t>
+            </a:r>
+            <a:r>
+              <a:rPr lang="it-IT" altLang="it-IT" sz="1400" i="1" dirty="0">
+                <a:latin typeface="+mn-lt"/>
+              </a:rPr>
+              <a:t>The Prestige</a:t>
+            </a:r>
+            <a:r>
+              <a:rPr lang="it-IT" altLang="it-IT" sz="1400" dirty="0">
+                <a:latin typeface="+mn-lt"/>
+              </a:rPr>
+              <a:t>, </a:t>
+            </a:r>
+            <a:r>
+              <a:rPr lang="it-IT" altLang="it-IT" sz="1400" i="1" dirty="0">
+                <a:latin typeface="+mn-lt"/>
+              </a:rPr>
+              <a:t>The Dark Knight</a:t>
+            </a:r>
+            <a:r>
+              <a:rPr lang="it-IT" altLang="it-IT" sz="1400" dirty="0">
+                <a:latin typeface="+mn-lt"/>
+              </a:rPr>
+              <a:t>, </a:t>
+            </a:r>
+            <a:r>
+              <a:rPr lang="it-IT" altLang="it-IT" sz="1400" i="1" dirty="0">
+                <a:latin typeface="+mn-lt"/>
+              </a:rPr>
+              <a:t>The Dark Knight Rises</a:t>
+            </a:r>
+            <a:r>
+              <a:rPr lang="it-IT" altLang="it-IT" sz="1400" dirty="0">
+                <a:latin typeface="+mn-lt"/>
+              </a:rPr>
+              <a:t>, </a:t>
+            </a:r>
+            <a:r>
+              <a:rPr lang="it-IT" altLang="it-IT" sz="1400" i="1" dirty="0">
+                <a:latin typeface="+mn-lt"/>
+              </a:rPr>
+              <a:t>Interstellar</a:t>
+            </a:r>
+            <a:r>
+              <a:rPr lang="it-IT" altLang="it-IT" sz="1400" dirty="0">
+                <a:latin typeface="+mn-lt"/>
+              </a:rPr>
+              <a:t>), la sua presenza….</a:t>
+            </a:r>
+            <a:endParaRPr kumimoji="0" lang="it-IT" altLang="it-IT" sz="1400" b="0" i="0" u="none" strike="noStrike" cap="none" normalizeH="0" baseline="0" dirty="0">
+              <a:ln>
+                <a:noFill/>
+              </a:ln>
+              <a:effectLst/>
+              <a:latin typeface="+mn-lt"/>
+            </a:endParaRPr>
           </a:p>
         </p:txBody>
       </p:sp>
@@ -3876,36 +4685,1097 @@
           <a:p>
             <a:r>
               <a:rPr lang="it-IT" dirty="0"/>
-              <a:t>Come mai uso gemini</a:t>
-            </a:r>
-          </a:p>
-        </p:txBody>
-      </p:sp>
-      <p:sp>
-        <p:nvSpPr>
-          <p:cNvPr id="3" name="Segnaposto contenuto 2">
-            <a:extLst>
-              <a:ext uri="{FF2B5EF4-FFF2-40B4-BE49-F238E27FC236}">
-                <a16:creationId xmlns:a16="http://schemas.microsoft.com/office/drawing/2014/main" id="{1AC78F24-ABA2-7D51-7AA7-A017673A5B7A}"/>
-              </a:ext>
-            </a:extLst>
-          </p:cNvPr>
-          <p:cNvSpPr>
-            <a:spLocks noGrp="1"/>
-          </p:cNvSpPr>
+              <a:t>Focus: Scelta dei modelli</a:t>
+            </a:r>
+          </a:p>
+        </p:txBody>
+      </p:sp>
+      <p:graphicFrame>
+        <p:nvGraphicFramePr>
+          <p:cNvPr id="4" name="Tabella 3">
+            <a:extLst>
+              <a:ext uri="{FF2B5EF4-FFF2-40B4-BE49-F238E27FC236}">
+                <a16:creationId xmlns:a16="http://schemas.microsoft.com/office/drawing/2014/main" id="{4E7AC48C-4182-6D2A-BD82-C004E6061594}"/>
+              </a:ext>
+            </a:extLst>
+          </p:cNvPr>
+          <p:cNvGraphicFramePr>
+            <a:graphicFrameLocks noGrp="1"/>
+          </p:cNvGraphicFramePr>
           <p:nvPr>
-            <p:ph idx="1"/>
+            <p:extLst>
+              <p:ext uri="{D42A27DB-BD31-4B8C-83A1-F6EECF244321}">
+                <p14:modId xmlns:p14="http://schemas.microsoft.com/office/powerpoint/2010/main" val="3906884155"/>
+              </p:ext>
+            </p:extLst>
           </p:nvPr>
-        </p:nvSpPr>
-        <p:spPr/>
-        <p:txBody>
-          <a:bodyPr/>
-          <a:lstStyle/>
-          <a:p>
-            <a:endParaRPr lang="it-IT"/>
-          </a:p>
-        </p:txBody>
-      </p:sp>
+        </p:nvGraphicFramePr>
+        <p:xfrm>
+          <a:off x="838200" y="1690688"/>
+          <a:ext cx="9238129" cy="2225040"/>
+        </p:xfrm>
+        <a:graphic>
+          <a:graphicData uri="http://schemas.openxmlformats.org/drawingml/2006/table">
+            <a:tbl>
+              <a:tblPr>
+                <a:tableStyleId>{93296810-A885-4BE3-A3E7-6D5BEEA58F35}</a:tableStyleId>
+              </a:tblPr>
+              <a:tblGrid>
+                <a:gridCol w="4200538">
+                  <a:extLst>
+                    <a:ext uri="{9D8B030D-6E8A-4147-A177-3AD203B41FA5}">
+                      <a16:colId xmlns:a16="http://schemas.microsoft.com/office/drawing/2014/main" val="2309301117"/>
+                    </a:ext>
+                  </a:extLst>
+                </a:gridCol>
+                <a:gridCol w="1142625">
+                  <a:extLst>
+                    <a:ext uri="{9D8B030D-6E8A-4147-A177-3AD203B41FA5}">
+                      <a16:colId xmlns:a16="http://schemas.microsoft.com/office/drawing/2014/main" val="3458894520"/>
+                    </a:ext>
+                  </a:extLst>
+                </a:gridCol>
+                <a:gridCol w="3894966">
+                  <a:extLst>
+                    <a:ext uri="{9D8B030D-6E8A-4147-A177-3AD203B41FA5}">
+                      <a16:colId xmlns:a16="http://schemas.microsoft.com/office/drawing/2014/main" val="2084396124"/>
+                    </a:ext>
+                  </a:extLst>
+                </a:gridCol>
+              </a:tblGrid>
+              <a:tr h="370840">
+                <a:tc>
+                  <a:txBody>
+                    <a:bodyPr/>
+                    <a:lstStyle/>
+                    <a:p>
+                      <a:r>
+                        <a:rPr lang="it-IT" b="1" dirty="0"/>
+                        <a:t>MODELLO</a:t>
+                      </a:r>
+                    </a:p>
+                  </a:txBody>
+                  <a:tcPr>
+                    <a:lnL w="12700" cap="flat" cmpd="sng" algn="ctr">
+                      <a:solidFill>
+                        <a:schemeClr val="tx1"/>
+                      </a:solidFill>
+                      <a:prstDash val="solid"/>
+                      <a:round/>
+                      <a:headEnd type="none" w="med" len="med"/>
+                      <a:tailEnd type="none" w="med" len="med"/>
+                    </a:lnL>
+                    <a:lnR w="12700" cap="flat" cmpd="sng" algn="ctr">
+                      <a:solidFill>
+                        <a:schemeClr val="tx1"/>
+                      </a:solidFill>
+                      <a:prstDash val="solid"/>
+                      <a:round/>
+                      <a:headEnd type="none" w="med" len="med"/>
+                      <a:tailEnd type="none" w="med" len="med"/>
+                    </a:lnR>
+                    <a:lnT w="12700" cap="flat" cmpd="sng" algn="ctr">
+                      <a:solidFill>
+                        <a:schemeClr val="tx1"/>
+                      </a:solidFill>
+                      <a:prstDash val="solid"/>
+                      <a:round/>
+                      <a:headEnd type="none" w="med" len="med"/>
+                      <a:tailEnd type="none" w="med" len="med"/>
+                    </a:lnT>
+                    <a:lnB w="12700" cap="flat" cmpd="sng" algn="ctr">
+                      <a:solidFill>
+                        <a:schemeClr val="tx1"/>
+                      </a:solidFill>
+                      <a:prstDash val="solid"/>
+                      <a:round/>
+                      <a:headEnd type="none" w="med" len="med"/>
+                      <a:tailEnd type="none" w="med" len="med"/>
+                    </a:lnB>
+                    <a:solidFill>
+                      <a:schemeClr val="bg1"/>
+                    </a:solidFill>
+                  </a:tcPr>
+                </a:tc>
+                <a:tc>
+                  <a:txBody>
+                    <a:bodyPr/>
+                    <a:lstStyle/>
+                    <a:p>
+                      <a:r>
+                        <a:rPr lang="it-IT" b="1" dirty="0"/>
+                        <a:t>ADATTO</a:t>
+                      </a:r>
+                    </a:p>
+                  </a:txBody>
+                  <a:tcPr>
+                    <a:lnL w="12700" cap="flat" cmpd="sng" algn="ctr">
+                      <a:solidFill>
+                        <a:schemeClr val="tx1"/>
+                      </a:solidFill>
+                      <a:prstDash val="solid"/>
+                      <a:round/>
+                      <a:headEnd type="none" w="med" len="med"/>
+                      <a:tailEnd type="none" w="med" len="med"/>
+                    </a:lnL>
+                    <a:lnR w="12700" cap="flat" cmpd="sng" algn="ctr">
+                      <a:solidFill>
+                        <a:schemeClr val="tx1"/>
+                      </a:solidFill>
+                      <a:prstDash val="solid"/>
+                      <a:round/>
+                      <a:headEnd type="none" w="med" len="med"/>
+                      <a:tailEnd type="none" w="med" len="med"/>
+                    </a:lnR>
+                    <a:lnT w="12700" cap="flat" cmpd="sng" algn="ctr">
+                      <a:solidFill>
+                        <a:schemeClr val="tx1"/>
+                      </a:solidFill>
+                      <a:prstDash val="solid"/>
+                      <a:round/>
+                      <a:headEnd type="none" w="med" len="med"/>
+                      <a:tailEnd type="none" w="med" len="med"/>
+                    </a:lnT>
+                    <a:lnB w="12700" cap="flat" cmpd="sng" algn="ctr">
+                      <a:solidFill>
+                        <a:schemeClr val="tx1"/>
+                      </a:solidFill>
+                      <a:prstDash val="solid"/>
+                      <a:round/>
+                      <a:headEnd type="none" w="med" len="med"/>
+                      <a:tailEnd type="none" w="med" len="med"/>
+                    </a:lnB>
+                    <a:solidFill>
+                      <a:schemeClr val="bg1"/>
+                    </a:solidFill>
+                  </a:tcPr>
+                </a:tc>
+                <a:tc>
+                  <a:txBody>
+                    <a:bodyPr/>
+                    <a:lstStyle/>
+                    <a:p>
+                      <a:r>
+                        <a:rPr lang="it-IT" b="1" dirty="0"/>
+                        <a:t>NOTE</a:t>
+                      </a:r>
+                    </a:p>
+                  </a:txBody>
+                  <a:tcPr>
+                    <a:lnL w="12700" cap="flat" cmpd="sng" algn="ctr">
+                      <a:solidFill>
+                        <a:schemeClr val="tx1"/>
+                      </a:solidFill>
+                      <a:prstDash val="solid"/>
+                      <a:round/>
+                      <a:headEnd type="none" w="med" len="med"/>
+                      <a:tailEnd type="none" w="med" len="med"/>
+                    </a:lnL>
+                    <a:lnR w="12700" cap="flat" cmpd="sng" algn="ctr">
+                      <a:solidFill>
+                        <a:schemeClr val="tx1"/>
+                      </a:solidFill>
+                      <a:prstDash val="solid"/>
+                      <a:round/>
+                      <a:headEnd type="none" w="med" len="med"/>
+                      <a:tailEnd type="none" w="med" len="med"/>
+                    </a:lnR>
+                    <a:lnT w="12700" cap="flat" cmpd="sng" algn="ctr">
+                      <a:solidFill>
+                        <a:schemeClr val="tx1"/>
+                      </a:solidFill>
+                      <a:prstDash val="solid"/>
+                      <a:round/>
+                      <a:headEnd type="none" w="med" len="med"/>
+                      <a:tailEnd type="none" w="med" len="med"/>
+                    </a:lnT>
+                    <a:lnB w="12700" cap="flat" cmpd="sng" algn="ctr">
+                      <a:solidFill>
+                        <a:schemeClr val="tx1"/>
+                      </a:solidFill>
+                      <a:prstDash val="solid"/>
+                      <a:round/>
+                      <a:headEnd type="none" w="med" len="med"/>
+                      <a:tailEnd type="none" w="med" len="med"/>
+                    </a:lnB>
+                    <a:solidFill>
+                      <a:schemeClr val="bg1"/>
+                    </a:solidFill>
+                  </a:tcPr>
+                </a:tc>
+                <a:extLst>
+                  <a:ext uri="{0D108BD9-81ED-4DB2-BD59-A6C34878D82A}">
+                    <a16:rowId xmlns:a16="http://schemas.microsoft.com/office/drawing/2014/main" val="3257491386"/>
+                  </a:ext>
+                </a:extLst>
+              </a:tr>
+              <a:tr h="370840">
+                <a:tc>
+                  <a:txBody>
+                    <a:bodyPr/>
+                    <a:lstStyle/>
+                    <a:p>
+                      <a:r>
+                        <a:rPr lang="it-IT" b="1" dirty="0"/>
+                        <a:t>gemini-3.5-flash</a:t>
+                      </a:r>
+                    </a:p>
+                  </a:txBody>
+                  <a:tcPr>
+                    <a:lnL w="12700" cap="flat" cmpd="sng" algn="ctr">
+                      <a:solidFill>
+                        <a:schemeClr val="tx1"/>
+                      </a:solidFill>
+                      <a:prstDash val="solid"/>
+                      <a:round/>
+                      <a:headEnd type="none" w="med" len="med"/>
+                      <a:tailEnd type="none" w="med" len="med"/>
+                    </a:lnL>
+                    <a:lnR w="12700" cap="flat" cmpd="sng" algn="ctr">
+                      <a:solidFill>
+                        <a:schemeClr val="tx1"/>
+                      </a:solidFill>
+                      <a:prstDash val="solid"/>
+                      <a:round/>
+                      <a:headEnd type="none" w="med" len="med"/>
+                      <a:tailEnd type="none" w="med" len="med"/>
+                    </a:lnR>
+                    <a:lnT w="12700" cap="flat" cmpd="sng" algn="ctr">
+                      <a:solidFill>
+                        <a:schemeClr val="tx1"/>
+                      </a:solidFill>
+                      <a:prstDash val="solid"/>
+                      <a:round/>
+                      <a:headEnd type="none" w="med" len="med"/>
+                      <a:tailEnd type="none" w="med" len="med"/>
+                    </a:lnT>
+                    <a:lnB w="12700" cap="flat" cmpd="sng" algn="ctr">
+                      <a:solidFill>
+                        <a:schemeClr val="tx1"/>
+                      </a:solidFill>
+                      <a:prstDash val="solid"/>
+                      <a:round/>
+                      <a:headEnd type="none" w="med" len="med"/>
+                      <a:tailEnd type="none" w="med" len="med"/>
+                    </a:lnB>
+                    <a:solidFill>
+                      <a:schemeClr val="accent6">
+                        <a:lumMod val="40000"/>
+                        <a:lumOff val="60000"/>
+                      </a:schemeClr>
+                    </a:solidFill>
+                  </a:tcPr>
+                </a:tc>
+                <a:tc>
+                  <a:txBody>
+                    <a:bodyPr/>
+                    <a:lstStyle/>
+                    <a:p>
+                      <a:r>
+                        <a:rPr lang="it-IT" dirty="0"/>
+                        <a:t>SI</a:t>
+                      </a:r>
+                    </a:p>
+                  </a:txBody>
+                  <a:tcPr>
+                    <a:lnL w="12700" cap="flat" cmpd="sng" algn="ctr">
+                      <a:solidFill>
+                        <a:schemeClr val="tx1"/>
+                      </a:solidFill>
+                      <a:prstDash val="solid"/>
+                      <a:round/>
+                      <a:headEnd type="none" w="med" len="med"/>
+                      <a:tailEnd type="none" w="med" len="med"/>
+                    </a:lnL>
+                    <a:lnR w="12700" cap="flat" cmpd="sng" algn="ctr">
+                      <a:solidFill>
+                        <a:schemeClr val="tx1"/>
+                      </a:solidFill>
+                      <a:prstDash val="solid"/>
+                      <a:round/>
+                      <a:headEnd type="none" w="med" len="med"/>
+                      <a:tailEnd type="none" w="med" len="med"/>
+                    </a:lnR>
+                    <a:lnT w="12700" cap="flat" cmpd="sng" algn="ctr">
+                      <a:solidFill>
+                        <a:schemeClr val="tx1"/>
+                      </a:solidFill>
+                      <a:prstDash val="solid"/>
+                      <a:round/>
+                      <a:headEnd type="none" w="med" len="med"/>
+                      <a:tailEnd type="none" w="med" len="med"/>
+                    </a:lnT>
+                    <a:lnB w="12700" cap="flat" cmpd="sng" algn="ctr">
+                      <a:solidFill>
+                        <a:schemeClr val="tx1"/>
+                      </a:solidFill>
+                      <a:prstDash val="solid"/>
+                      <a:round/>
+                      <a:headEnd type="none" w="med" len="med"/>
+                      <a:tailEnd type="none" w="med" len="med"/>
+                    </a:lnB>
+                    <a:solidFill>
+                      <a:schemeClr val="accent6">
+                        <a:lumMod val="40000"/>
+                        <a:lumOff val="60000"/>
+                      </a:schemeClr>
+                    </a:solidFill>
+                  </a:tcPr>
+                </a:tc>
+                <a:tc>
+                  <a:txBody>
+                    <a:bodyPr/>
+                    <a:lstStyle/>
+                    <a:p>
+                      <a:endParaRPr lang="it-IT" dirty="0"/>
+                    </a:p>
+                  </a:txBody>
+                  <a:tcPr>
+                    <a:lnL w="12700" cap="flat" cmpd="sng" algn="ctr">
+                      <a:solidFill>
+                        <a:schemeClr val="tx1"/>
+                      </a:solidFill>
+                      <a:prstDash val="solid"/>
+                      <a:round/>
+                      <a:headEnd type="none" w="med" len="med"/>
+                      <a:tailEnd type="none" w="med" len="med"/>
+                    </a:lnL>
+                    <a:lnR w="12700" cap="flat" cmpd="sng" algn="ctr">
+                      <a:solidFill>
+                        <a:schemeClr val="tx1"/>
+                      </a:solidFill>
+                      <a:prstDash val="solid"/>
+                      <a:round/>
+                      <a:headEnd type="none" w="med" len="med"/>
+                      <a:tailEnd type="none" w="med" len="med"/>
+                    </a:lnR>
+                    <a:lnT w="12700" cap="flat" cmpd="sng" algn="ctr">
+                      <a:solidFill>
+                        <a:schemeClr val="tx1"/>
+                      </a:solidFill>
+                      <a:prstDash val="solid"/>
+                      <a:round/>
+                      <a:headEnd type="none" w="med" len="med"/>
+                      <a:tailEnd type="none" w="med" len="med"/>
+                    </a:lnT>
+                    <a:lnB w="12700" cap="flat" cmpd="sng" algn="ctr">
+                      <a:solidFill>
+                        <a:schemeClr val="tx1"/>
+                      </a:solidFill>
+                      <a:prstDash val="solid"/>
+                      <a:round/>
+                      <a:headEnd type="none" w="med" len="med"/>
+                      <a:tailEnd type="none" w="med" len="med"/>
+                    </a:lnB>
+                    <a:solidFill>
+                      <a:schemeClr val="accent6">
+                        <a:lumMod val="40000"/>
+                        <a:lumOff val="60000"/>
+                      </a:schemeClr>
+                    </a:solidFill>
+                  </a:tcPr>
+                </a:tc>
+                <a:extLst>
+                  <a:ext uri="{0D108BD9-81ED-4DB2-BD59-A6C34878D82A}">
+                    <a16:rowId xmlns:a16="http://schemas.microsoft.com/office/drawing/2014/main" val="708098783"/>
+                  </a:ext>
+                </a:extLst>
+              </a:tr>
+              <a:tr h="370840">
+                <a:tc>
+                  <a:txBody>
+                    <a:bodyPr/>
+                    <a:lstStyle/>
+                    <a:p>
+                      <a:r>
+                        <a:rPr lang="it-IT" dirty="0"/>
+                        <a:t>Groq - openai/gpt-oss-20b</a:t>
+                      </a:r>
+                    </a:p>
+                  </a:txBody>
+                  <a:tcPr>
+                    <a:lnL w="12700" cap="flat" cmpd="sng" algn="ctr">
+                      <a:solidFill>
+                        <a:schemeClr val="tx1"/>
+                      </a:solidFill>
+                      <a:prstDash val="solid"/>
+                      <a:round/>
+                      <a:headEnd type="none" w="med" len="med"/>
+                      <a:tailEnd type="none" w="med" len="med"/>
+                    </a:lnL>
+                    <a:lnR w="12700" cap="flat" cmpd="sng" algn="ctr">
+                      <a:solidFill>
+                        <a:schemeClr val="tx1"/>
+                      </a:solidFill>
+                      <a:prstDash val="solid"/>
+                      <a:round/>
+                      <a:headEnd type="none" w="med" len="med"/>
+                      <a:tailEnd type="none" w="med" len="med"/>
+                    </a:lnR>
+                    <a:lnT w="12700" cap="flat" cmpd="sng" algn="ctr">
+                      <a:solidFill>
+                        <a:schemeClr val="tx1"/>
+                      </a:solidFill>
+                      <a:prstDash val="solid"/>
+                      <a:round/>
+                      <a:headEnd type="none" w="med" len="med"/>
+                      <a:tailEnd type="none" w="med" len="med"/>
+                    </a:lnT>
+                    <a:lnB w="12700" cap="flat" cmpd="sng" algn="ctr">
+                      <a:solidFill>
+                        <a:schemeClr val="tx1"/>
+                      </a:solidFill>
+                      <a:prstDash val="solid"/>
+                      <a:round/>
+                      <a:headEnd type="none" w="med" len="med"/>
+                      <a:tailEnd type="none" w="med" len="med"/>
+                    </a:lnB>
+                    <a:solidFill>
+                      <a:schemeClr val="bg1"/>
+                    </a:solidFill>
+                  </a:tcPr>
+                </a:tc>
+                <a:tc>
+                  <a:txBody>
+                    <a:bodyPr/>
+                    <a:lstStyle/>
+                    <a:p>
+                      <a:r>
+                        <a:rPr lang="it-IT" dirty="0"/>
+                        <a:t>NO</a:t>
+                      </a:r>
+                    </a:p>
+                  </a:txBody>
+                  <a:tcPr>
+                    <a:lnL w="12700" cap="flat" cmpd="sng" algn="ctr">
+                      <a:solidFill>
+                        <a:schemeClr val="tx1"/>
+                      </a:solidFill>
+                      <a:prstDash val="solid"/>
+                      <a:round/>
+                      <a:headEnd type="none" w="med" len="med"/>
+                      <a:tailEnd type="none" w="med" len="med"/>
+                    </a:lnL>
+                    <a:lnR w="12700" cap="flat" cmpd="sng" algn="ctr">
+                      <a:solidFill>
+                        <a:schemeClr val="tx1"/>
+                      </a:solidFill>
+                      <a:prstDash val="solid"/>
+                      <a:round/>
+                      <a:headEnd type="none" w="med" len="med"/>
+                      <a:tailEnd type="none" w="med" len="med"/>
+                    </a:lnR>
+                    <a:lnT w="12700" cap="flat" cmpd="sng" algn="ctr">
+                      <a:solidFill>
+                        <a:schemeClr val="tx1"/>
+                      </a:solidFill>
+                      <a:prstDash val="solid"/>
+                      <a:round/>
+                      <a:headEnd type="none" w="med" len="med"/>
+                      <a:tailEnd type="none" w="med" len="med"/>
+                    </a:lnT>
+                    <a:lnB w="12700" cap="flat" cmpd="sng" algn="ctr">
+                      <a:solidFill>
+                        <a:schemeClr val="tx1"/>
+                      </a:solidFill>
+                      <a:prstDash val="solid"/>
+                      <a:round/>
+                      <a:headEnd type="none" w="med" len="med"/>
+                      <a:tailEnd type="none" w="med" len="med"/>
+                    </a:lnB>
+                    <a:solidFill>
+                      <a:schemeClr val="bg1"/>
+                    </a:solidFill>
+                  </a:tcPr>
+                </a:tc>
+                <a:tc>
+                  <a:txBody>
+                    <a:bodyPr/>
+                    <a:lstStyle/>
+                    <a:p>
+                      <a:r>
+                        <a:rPr lang="it-IT" dirty="0"/>
+                        <a:t>Inaffidabile nel tool-</a:t>
+                      </a:r>
+                      <a:r>
+                        <a:rPr lang="it-IT" dirty="0" err="1"/>
+                        <a:t>calling</a:t>
+                      </a:r>
+                      <a:endParaRPr lang="it-IT" dirty="0"/>
+                    </a:p>
+                  </a:txBody>
+                  <a:tcPr>
+                    <a:lnL w="12700" cap="flat" cmpd="sng" algn="ctr">
+                      <a:solidFill>
+                        <a:schemeClr val="tx1"/>
+                      </a:solidFill>
+                      <a:prstDash val="solid"/>
+                      <a:round/>
+                      <a:headEnd type="none" w="med" len="med"/>
+                      <a:tailEnd type="none" w="med" len="med"/>
+                    </a:lnL>
+                    <a:lnR w="12700" cap="flat" cmpd="sng" algn="ctr">
+                      <a:solidFill>
+                        <a:schemeClr val="tx1"/>
+                      </a:solidFill>
+                      <a:prstDash val="solid"/>
+                      <a:round/>
+                      <a:headEnd type="none" w="med" len="med"/>
+                      <a:tailEnd type="none" w="med" len="med"/>
+                    </a:lnR>
+                    <a:lnT w="12700" cap="flat" cmpd="sng" algn="ctr">
+                      <a:solidFill>
+                        <a:schemeClr val="tx1"/>
+                      </a:solidFill>
+                      <a:prstDash val="solid"/>
+                      <a:round/>
+                      <a:headEnd type="none" w="med" len="med"/>
+                      <a:tailEnd type="none" w="med" len="med"/>
+                    </a:lnT>
+                    <a:lnB w="12700" cap="flat" cmpd="sng" algn="ctr">
+                      <a:solidFill>
+                        <a:schemeClr val="tx1"/>
+                      </a:solidFill>
+                      <a:prstDash val="solid"/>
+                      <a:round/>
+                      <a:headEnd type="none" w="med" len="med"/>
+                      <a:tailEnd type="none" w="med" len="med"/>
+                    </a:lnB>
+                    <a:solidFill>
+                      <a:schemeClr val="bg1"/>
+                    </a:solidFill>
+                  </a:tcPr>
+                </a:tc>
+                <a:extLst>
+                  <a:ext uri="{0D108BD9-81ED-4DB2-BD59-A6C34878D82A}">
+                    <a16:rowId xmlns:a16="http://schemas.microsoft.com/office/drawing/2014/main" val="524267894"/>
+                  </a:ext>
+                </a:extLst>
+              </a:tr>
+              <a:tr h="370840">
+                <a:tc>
+                  <a:txBody>
+                    <a:bodyPr/>
+                    <a:lstStyle/>
+                    <a:p>
+                      <a:r>
+                        <a:rPr lang="it-IT" dirty="0"/>
+                        <a:t>Groq - openai/gpt-oss-120b</a:t>
+                      </a:r>
+                    </a:p>
+                  </a:txBody>
+                  <a:tcPr>
+                    <a:lnL w="12700" cap="flat" cmpd="sng" algn="ctr">
+                      <a:solidFill>
+                        <a:schemeClr val="tx1"/>
+                      </a:solidFill>
+                      <a:prstDash val="solid"/>
+                      <a:round/>
+                      <a:headEnd type="none" w="med" len="med"/>
+                      <a:tailEnd type="none" w="med" len="med"/>
+                    </a:lnL>
+                    <a:lnR w="12700" cap="flat" cmpd="sng" algn="ctr">
+                      <a:solidFill>
+                        <a:schemeClr val="tx1"/>
+                      </a:solidFill>
+                      <a:prstDash val="solid"/>
+                      <a:round/>
+                      <a:headEnd type="none" w="med" len="med"/>
+                      <a:tailEnd type="none" w="med" len="med"/>
+                    </a:lnR>
+                    <a:lnT w="12700" cap="flat" cmpd="sng" algn="ctr">
+                      <a:solidFill>
+                        <a:schemeClr val="tx1"/>
+                      </a:solidFill>
+                      <a:prstDash val="solid"/>
+                      <a:round/>
+                      <a:headEnd type="none" w="med" len="med"/>
+                      <a:tailEnd type="none" w="med" len="med"/>
+                    </a:lnT>
+                    <a:lnB w="12700" cap="flat" cmpd="sng" algn="ctr">
+                      <a:solidFill>
+                        <a:schemeClr val="tx1"/>
+                      </a:solidFill>
+                      <a:prstDash val="solid"/>
+                      <a:round/>
+                      <a:headEnd type="none" w="med" len="med"/>
+                      <a:tailEnd type="none" w="med" len="med"/>
+                    </a:lnB>
+                    <a:solidFill>
+                      <a:schemeClr val="bg1"/>
+                    </a:solidFill>
+                  </a:tcPr>
+                </a:tc>
+                <a:tc>
+                  <a:txBody>
+                    <a:bodyPr/>
+                    <a:lstStyle/>
+                    <a:p>
+                      <a:r>
+                        <a:rPr lang="it-IT" dirty="0"/>
+                        <a:t>NO</a:t>
+                      </a:r>
+                    </a:p>
+                  </a:txBody>
+                  <a:tcPr>
+                    <a:lnL w="12700" cap="flat" cmpd="sng" algn="ctr">
+                      <a:solidFill>
+                        <a:schemeClr val="tx1"/>
+                      </a:solidFill>
+                      <a:prstDash val="solid"/>
+                      <a:round/>
+                      <a:headEnd type="none" w="med" len="med"/>
+                      <a:tailEnd type="none" w="med" len="med"/>
+                    </a:lnL>
+                    <a:lnR w="12700" cap="flat" cmpd="sng" algn="ctr">
+                      <a:solidFill>
+                        <a:schemeClr val="tx1"/>
+                      </a:solidFill>
+                      <a:prstDash val="solid"/>
+                      <a:round/>
+                      <a:headEnd type="none" w="med" len="med"/>
+                      <a:tailEnd type="none" w="med" len="med"/>
+                    </a:lnR>
+                    <a:lnT w="12700" cap="flat" cmpd="sng" algn="ctr">
+                      <a:solidFill>
+                        <a:schemeClr val="tx1"/>
+                      </a:solidFill>
+                      <a:prstDash val="solid"/>
+                      <a:round/>
+                      <a:headEnd type="none" w="med" len="med"/>
+                      <a:tailEnd type="none" w="med" len="med"/>
+                    </a:lnT>
+                    <a:lnB w="12700" cap="flat" cmpd="sng" algn="ctr">
+                      <a:solidFill>
+                        <a:schemeClr val="tx1"/>
+                      </a:solidFill>
+                      <a:prstDash val="solid"/>
+                      <a:round/>
+                      <a:headEnd type="none" w="med" len="med"/>
+                      <a:tailEnd type="none" w="med" len="med"/>
+                    </a:lnB>
+                    <a:solidFill>
+                      <a:schemeClr val="bg1"/>
+                    </a:solidFill>
+                  </a:tcPr>
+                </a:tc>
+                <a:tc>
+                  <a:txBody>
+                    <a:bodyPr/>
+                    <a:lstStyle/>
+                    <a:p>
+                      <a:r>
+                        <a:rPr lang="it-IT" dirty="0"/>
+                        <a:t>Inaffidabile nel tool-</a:t>
+                      </a:r>
+                      <a:r>
+                        <a:rPr lang="it-IT" dirty="0" err="1"/>
+                        <a:t>calling</a:t>
+                      </a:r>
+                      <a:r>
+                        <a:rPr lang="it-IT" dirty="0"/>
+                        <a:t> multiplo</a:t>
+                      </a:r>
+                    </a:p>
+                  </a:txBody>
+                  <a:tcPr>
+                    <a:lnL w="12700" cap="flat" cmpd="sng" algn="ctr">
+                      <a:solidFill>
+                        <a:schemeClr val="tx1"/>
+                      </a:solidFill>
+                      <a:prstDash val="solid"/>
+                      <a:round/>
+                      <a:headEnd type="none" w="med" len="med"/>
+                      <a:tailEnd type="none" w="med" len="med"/>
+                    </a:lnL>
+                    <a:lnR w="12700" cap="flat" cmpd="sng" algn="ctr">
+                      <a:solidFill>
+                        <a:schemeClr val="tx1"/>
+                      </a:solidFill>
+                      <a:prstDash val="solid"/>
+                      <a:round/>
+                      <a:headEnd type="none" w="med" len="med"/>
+                      <a:tailEnd type="none" w="med" len="med"/>
+                    </a:lnR>
+                    <a:lnT w="12700" cap="flat" cmpd="sng" algn="ctr">
+                      <a:solidFill>
+                        <a:schemeClr val="tx1"/>
+                      </a:solidFill>
+                      <a:prstDash val="solid"/>
+                      <a:round/>
+                      <a:headEnd type="none" w="med" len="med"/>
+                      <a:tailEnd type="none" w="med" len="med"/>
+                    </a:lnT>
+                    <a:lnB w="12700" cap="flat" cmpd="sng" algn="ctr">
+                      <a:solidFill>
+                        <a:schemeClr val="tx1"/>
+                      </a:solidFill>
+                      <a:prstDash val="solid"/>
+                      <a:round/>
+                      <a:headEnd type="none" w="med" len="med"/>
+                      <a:tailEnd type="none" w="med" len="med"/>
+                    </a:lnB>
+                    <a:solidFill>
+                      <a:schemeClr val="bg1"/>
+                    </a:solidFill>
+                  </a:tcPr>
+                </a:tc>
+                <a:extLst>
+                  <a:ext uri="{0D108BD9-81ED-4DB2-BD59-A6C34878D82A}">
+                    <a16:rowId xmlns:a16="http://schemas.microsoft.com/office/drawing/2014/main" val="3068148050"/>
+                  </a:ext>
+                </a:extLst>
+              </a:tr>
+              <a:tr h="370840">
+                <a:tc>
+                  <a:txBody>
+                    <a:bodyPr/>
+                    <a:lstStyle/>
+                    <a:p>
+                      <a:r>
+                        <a:rPr lang="it-IT" dirty="0"/>
+                        <a:t>Groq/compound</a:t>
+                      </a:r>
+                    </a:p>
+                  </a:txBody>
+                  <a:tcPr>
+                    <a:lnL w="12700" cap="flat" cmpd="sng" algn="ctr">
+                      <a:solidFill>
+                        <a:schemeClr val="tx1"/>
+                      </a:solidFill>
+                      <a:prstDash val="solid"/>
+                      <a:round/>
+                      <a:headEnd type="none" w="med" len="med"/>
+                      <a:tailEnd type="none" w="med" len="med"/>
+                    </a:lnL>
+                    <a:lnR w="12700" cap="flat" cmpd="sng" algn="ctr">
+                      <a:solidFill>
+                        <a:schemeClr val="tx1"/>
+                      </a:solidFill>
+                      <a:prstDash val="solid"/>
+                      <a:round/>
+                      <a:headEnd type="none" w="med" len="med"/>
+                      <a:tailEnd type="none" w="med" len="med"/>
+                    </a:lnR>
+                    <a:lnT w="12700" cap="flat" cmpd="sng" algn="ctr">
+                      <a:solidFill>
+                        <a:schemeClr val="tx1"/>
+                      </a:solidFill>
+                      <a:prstDash val="solid"/>
+                      <a:round/>
+                      <a:headEnd type="none" w="med" len="med"/>
+                      <a:tailEnd type="none" w="med" len="med"/>
+                    </a:lnT>
+                    <a:lnB w="12700" cap="flat" cmpd="sng" algn="ctr">
+                      <a:solidFill>
+                        <a:schemeClr val="tx1"/>
+                      </a:solidFill>
+                      <a:prstDash val="solid"/>
+                      <a:round/>
+                      <a:headEnd type="none" w="med" len="med"/>
+                      <a:tailEnd type="none" w="med" len="med"/>
+                    </a:lnB>
+                    <a:solidFill>
+                      <a:schemeClr val="bg1"/>
+                    </a:solidFill>
+                  </a:tcPr>
+                </a:tc>
+                <a:tc>
+                  <a:txBody>
+                    <a:bodyPr/>
+                    <a:lstStyle/>
+                    <a:p>
+                      <a:r>
+                        <a:rPr lang="it-IT" dirty="0"/>
+                        <a:t>NO</a:t>
+                      </a:r>
+                    </a:p>
+                  </a:txBody>
+                  <a:tcPr>
+                    <a:lnL w="12700" cap="flat" cmpd="sng" algn="ctr">
+                      <a:solidFill>
+                        <a:schemeClr val="tx1"/>
+                      </a:solidFill>
+                      <a:prstDash val="solid"/>
+                      <a:round/>
+                      <a:headEnd type="none" w="med" len="med"/>
+                      <a:tailEnd type="none" w="med" len="med"/>
+                    </a:lnL>
+                    <a:lnR w="12700" cap="flat" cmpd="sng" algn="ctr">
+                      <a:solidFill>
+                        <a:schemeClr val="tx1"/>
+                      </a:solidFill>
+                      <a:prstDash val="solid"/>
+                      <a:round/>
+                      <a:headEnd type="none" w="med" len="med"/>
+                      <a:tailEnd type="none" w="med" len="med"/>
+                    </a:lnR>
+                    <a:lnT w="12700" cap="flat" cmpd="sng" algn="ctr">
+                      <a:solidFill>
+                        <a:schemeClr val="tx1"/>
+                      </a:solidFill>
+                      <a:prstDash val="solid"/>
+                      <a:round/>
+                      <a:headEnd type="none" w="med" len="med"/>
+                      <a:tailEnd type="none" w="med" len="med"/>
+                    </a:lnT>
+                    <a:lnB w="12700" cap="flat" cmpd="sng" algn="ctr">
+                      <a:solidFill>
+                        <a:schemeClr val="tx1"/>
+                      </a:solidFill>
+                      <a:prstDash val="solid"/>
+                      <a:round/>
+                      <a:headEnd type="none" w="med" len="med"/>
+                      <a:tailEnd type="none" w="med" len="med"/>
+                    </a:lnB>
+                    <a:solidFill>
+                      <a:schemeClr val="bg1"/>
+                    </a:solidFill>
+                  </a:tcPr>
+                </a:tc>
+                <a:tc>
+                  <a:txBody>
+                    <a:bodyPr/>
+                    <a:lstStyle/>
+                    <a:p>
+                      <a:r>
+                        <a:rPr lang="it-IT" dirty="0"/>
+                        <a:t>Non supporta tool-</a:t>
+                      </a:r>
+                      <a:r>
+                        <a:rPr lang="it-IT" dirty="0" err="1"/>
+                        <a:t>calling</a:t>
+                      </a:r>
+                      <a:endParaRPr lang="it-IT" dirty="0"/>
+                    </a:p>
+                  </a:txBody>
+                  <a:tcPr>
+                    <a:lnL w="12700" cap="flat" cmpd="sng" algn="ctr">
+                      <a:solidFill>
+                        <a:schemeClr val="tx1"/>
+                      </a:solidFill>
+                      <a:prstDash val="solid"/>
+                      <a:round/>
+                      <a:headEnd type="none" w="med" len="med"/>
+                      <a:tailEnd type="none" w="med" len="med"/>
+                    </a:lnL>
+                    <a:lnR w="12700" cap="flat" cmpd="sng" algn="ctr">
+                      <a:solidFill>
+                        <a:schemeClr val="tx1"/>
+                      </a:solidFill>
+                      <a:prstDash val="solid"/>
+                      <a:round/>
+                      <a:headEnd type="none" w="med" len="med"/>
+                      <a:tailEnd type="none" w="med" len="med"/>
+                    </a:lnR>
+                    <a:lnT w="12700" cap="flat" cmpd="sng" algn="ctr">
+                      <a:solidFill>
+                        <a:schemeClr val="tx1"/>
+                      </a:solidFill>
+                      <a:prstDash val="solid"/>
+                      <a:round/>
+                      <a:headEnd type="none" w="med" len="med"/>
+                      <a:tailEnd type="none" w="med" len="med"/>
+                    </a:lnT>
+                    <a:lnB w="12700" cap="flat" cmpd="sng" algn="ctr">
+                      <a:solidFill>
+                        <a:schemeClr val="tx1"/>
+                      </a:solidFill>
+                      <a:prstDash val="solid"/>
+                      <a:round/>
+                      <a:headEnd type="none" w="med" len="med"/>
+                      <a:tailEnd type="none" w="med" len="med"/>
+                    </a:lnB>
+                    <a:solidFill>
+                      <a:schemeClr val="bg1"/>
+                    </a:solidFill>
+                  </a:tcPr>
+                </a:tc>
+                <a:extLst>
+                  <a:ext uri="{0D108BD9-81ED-4DB2-BD59-A6C34878D82A}">
+                    <a16:rowId xmlns:a16="http://schemas.microsoft.com/office/drawing/2014/main" val="1881908015"/>
+                  </a:ext>
+                </a:extLst>
+              </a:tr>
+              <a:tr h="370840">
+                <a:tc>
+                  <a:txBody>
+                    <a:bodyPr/>
+                    <a:lstStyle/>
+                    <a:p>
+                      <a:r>
+                        <a:rPr lang="it-IT" b="1" dirty="0"/>
+                        <a:t>Groq - qwen/qwen3.8-27b</a:t>
+                      </a:r>
+                    </a:p>
+                  </a:txBody>
+                  <a:tcPr>
+                    <a:lnL w="12700" cap="flat" cmpd="sng" algn="ctr">
+                      <a:solidFill>
+                        <a:schemeClr val="tx1"/>
+                      </a:solidFill>
+                      <a:prstDash val="solid"/>
+                      <a:round/>
+                      <a:headEnd type="none" w="med" len="med"/>
+                      <a:tailEnd type="none" w="med" len="med"/>
+                    </a:lnL>
+                    <a:lnR w="12700" cap="flat" cmpd="sng" algn="ctr">
+                      <a:solidFill>
+                        <a:schemeClr val="tx1"/>
+                      </a:solidFill>
+                      <a:prstDash val="solid"/>
+                      <a:round/>
+                      <a:headEnd type="none" w="med" len="med"/>
+                      <a:tailEnd type="none" w="med" len="med"/>
+                    </a:lnR>
+                    <a:lnT w="12700" cap="flat" cmpd="sng" algn="ctr">
+                      <a:solidFill>
+                        <a:schemeClr val="tx1"/>
+                      </a:solidFill>
+                      <a:prstDash val="solid"/>
+                      <a:round/>
+                      <a:headEnd type="none" w="med" len="med"/>
+                      <a:tailEnd type="none" w="med" len="med"/>
+                    </a:lnT>
+                    <a:lnB w="12700" cap="flat" cmpd="sng" algn="ctr">
+                      <a:solidFill>
+                        <a:schemeClr val="tx1"/>
+                      </a:solidFill>
+                      <a:prstDash val="solid"/>
+                      <a:round/>
+                      <a:headEnd type="none" w="med" len="med"/>
+                      <a:tailEnd type="none" w="med" len="med"/>
+                    </a:lnB>
+                    <a:solidFill>
+                      <a:schemeClr val="accent4">
+                        <a:lumMod val="40000"/>
+                        <a:lumOff val="60000"/>
+                      </a:schemeClr>
+                    </a:solidFill>
+                  </a:tcPr>
+                </a:tc>
+                <a:tc>
+                  <a:txBody>
+                    <a:bodyPr/>
+                    <a:lstStyle/>
+                    <a:p>
+                      <a:r>
+                        <a:rPr lang="it-IT" dirty="0"/>
+                        <a:t>SI</a:t>
+                      </a:r>
+                    </a:p>
+                  </a:txBody>
+                  <a:tcPr>
+                    <a:lnL w="12700" cap="flat" cmpd="sng" algn="ctr">
+                      <a:solidFill>
+                        <a:schemeClr val="tx1"/>
+                      </a:solidFill>
+                      <a:prstDash val="solid"/>
+                      <a:round/>
+                      <a:headEnd type="none" w="med" len="med"/>
+                      <a:tailEnd type="none" w="med" len="med"/>
+                    </a:lnL>
+                    <a:lnR w="12700" cap="flat" cmpd="sng" algn="ctr">
+                      <a:solidFill>
+                        <a:schemeClr val="tx1"/>
+                      </a:solidFill>
+                      <a:prstDash val="solid"/>
+                      <a:round/>
+                      <a:headEnd type="none" w="med" len="med"/>
+                      <a:tailEnd type="none" w="med" len="med"/>
+                    </a:lnR>
+                    <a:lnT w="12700" cap="flat" cmpd="sng" algn="ctr">
+                      <a:solidFill>
+                        <a:schemeClr val="tx1"/>
+                      </a:solidFill>
+                      <a:prstDash val="solid"/>
+                      <a:round/>
+                      <a:headEnd type="none" w="med" len="med"/>
+                      <a:tailEnd type="none" w="med" len="med"/>
+                    </a:lnT>
+                    <a:lnB w="12700" cap="flat" cmpd="sng" algn="ctr">
+                      <a:solidFill>
+                        <a:schemeClr val="tx1"/>
+                      </a:solidFill>
+                      <a:prstDash val="solid"/>
+                      <a:round/>
+                      <a:headEnd type="none" w="med" len="med"/>
+                      <a:tailEnd type="none" w="med" len="med"/>
+                    </a:lnB>
+                    <a:solidFill>
+                      <a:schemeClr val="accent4">
+                        <a:lumMod val="40000"/>
+                        <a:lumOff val="60000"/>
+                      </a:schemeClr>
+                    </a:solidFill>
+                  </a:tcPr>
+                </a:tc>
+                <a:tc>
+                  <a:txBody>
+                    <a:bodyPr/>
+                    <a:lstStyle/>
+                    <a:p>
+                      <a:r>
+                        <a:rPr lang="it-IT" dirty="0"/>
+                        <a:t>Richiede reasoning_format="hidden"</a:t>
+                      </a:r>
+                    </a:p>
+                  </a:txBody>
+                  <a:tcPr>
+                    <a:lnL w="12700" cap="flat" cmpd="sng" algn="ctr">
+                      <a:solidFill>
+                        <a:schemeClr val="tx1"/>
+                      </a:solidFill>
+                      <a:prstDash val="solid"/>
+                      <a:round/>
+                      <a:headEnd type="none" w="med" len="med"/>
+                      <a:tailEnd type="none" w="med" len="med"/>
+                    </a:lnL>
+                    <a:lnR w="12700" cap="flat" cmpd="sng" algn="ctr">
+                      <a:solidFill>
+                        <a:schemeClr val="tx1"/>
+                      </a:solidFill>
+                      <a:prstDash val="solid"/>
+                      <a:round/>
+                      <a:headEnd type="none" w="med" len="med"/>
+                      <a:tailEnd type="none" w="med" len="med"/>
+                    </a:lnR>
+                    <a:lnT w="12700" cap="flat" cmpd="sng" algn="ctr">
+                      <a:solidFill>
+                        <a:schemeClr val="tx1"/>
+                      </a:solidFill>
+                      <a:prstDash val="solid"/>
+                      <a:round/>
+                      <a:headEnd type="none" w="med" len="med"/>
+                      <a:tailEnd type="none" w="med" len="med"/>
+                    </a:lnT>
+                    <a:lnB w="12700" cap="flat" cmpd="sng" algn="ctr">
+                      <a:solidFill>
+                        <a:schemeClr val="tx1"/>
+                      </a:solidFill>
+                      <a:prstDash val="solid"/>
+                      <a:round/>
+                      <a:headEnd type="none" w="med" len="med"/>
+                      <a:tailEnd type="none" w="med" len="med"/>
+                    </a:lnB>
+                    <a:solidFill>
+                      <a:schemeClr val="accent4">
+                        <a:lumMod val="40000"/>
+                        <a:lumOff val="60000"/>
+                      </a:schemeClr>
+                    </a:solidFill>
+                  </a:tcPr>
+                </a:tc>
+                <a:extLst>
+                  <a:ext uri="{0D108BD9-81ED-4DB2-BD59-A6C34878D82A}">
+                    <a16:rowId xmlns:a16="http://schemas.microsoft.com/office/drawing/2014/main" val="232861777"/>
+                  </a:ext>
+                </a:extLst>
+              </a:tr>
+            </a:tbl>
+          </a:graphicData>
+        </a:graphic>
+      </p:graphicFrame>
     </p:spTree>
     <p:extLst>
       <p:ext uri="{BB962C8B-B14F-4D97-AF65-F5344CB8AC3E}">
@@ -3924,7 +5794,13 @@
   <p:cSld>
     <p:spTree>
       <p:nvGrpSpPr>
-        <p:cNvPr id="1" name=""/>
+        <p:cNvPr id="1" name="">
+          <a:extLst>
+            <a:ext uri="{FF2B5EF4-FFF2-40B4-BE49-F238E27FC236}">
+              <a16:creationId xmlns:a16="http://schemas.microsoft.com/office/drawing/2014/main" id="{84629325-8F5F-2778-22D6-96394B19E425}"/>
+            </a:ext>
+          </a:extLst>
+        </p:cNvPr>
         <p:cNvGrpSpPr/>
         <p:nvPr/>
       </p:nvGrpSpPr>
@@ -3941,7 +5817,7 @@
           <p:cNvPr id="2" name="Titolo 1">
             <a:extLst>
               <a:ext uri="{FF2B5EF4-FFF2-40B4-BE49-F238E27FC236}">
-                <a16:creationId xmlns:a16="http://schemas.microsoft.com/office/drawing/2014/main" id="{A7FBE056-0EB8-A3BF-BA85-E1B209C740AB}"/>
+                <a16:creationId xmlns:a16="http://schemas.microsoft.com/office/drawing/2014/main" id="{0DDA76EB-E89A-5251-87FC-ED317EB97690}"/>
               </a:ext>
             </a:extLst>
           </p:cNvPr>
@@ -3959,35 +5835,936 @@
           <a:p>
             <a:r>
               <a:rPr lang="it-IT" dirty="0"/>
-              <a:t>Stima costi unitari (in token)</a:t>
-            </a:r>
-          </a:p>
-        </p:txBody>
-      </p:sp>
-      <p:sp>
-        <p:nvSpPr>
-          <p:cNvPr id="3" name="Segnaposto contenuto 2">
-            <a:extLst>
-              <a:ext uri="{FF2B5EF4-FFF2-40B4-BE49-F238E27FC236}">
-                <a16:creationId xmlns:a16="http://schemas.microsoft.com/office/drawing/2014/main" id="{9595EADE-AEC4-DD75-437C-AD73F59201C2}"/>
-              </a:ext>
-            </a:extLst>
-          </p:cNvPr>
-          <p:cNvSpPr>
-            <a:spLocks noGrp="1"/>
-          </p:cNvSpPr>
+              <a:t>Fallback</a:t>
+            </a:r>
+          </a:p>
+        </p:txBody>
+      </p:sp>
+      <p:graphicFrame>
+        <p:nvGraphicFramePr>
+          <p:cNvPr id="6" name="Tabella 5">
+            <a:extLst>
+              <a:ext uri="{FF2B5EF4-FFF2-40B4-BE49-F238E27FC236}">
+                <a16:creationId xmlns:a16="http://schemas.microsoft.com/office/drawing/2014/main" id="{1ACCCF0C-9AB0-15CB-26B3-DEC9C1E19FF3}"/>
+              </a:ext>
+            </a:extLst>
+          </p:cNvPr>
+          <p:cNvGraphicFramePr>
+            <a:graphicFrameLocks noGrp="1"/>
+          </p:cNvGraphicFramePr>
           <p:nvPr>
-            <p:ph idx="1"/>
+            <p:extLst>
+              <p:ext uri="{D42A27DB-BD31-4B8C-83A1-F6EECF244321}">
+                <p14:modId xmlns:p14="http://schemas.microsoft.com/office/powerpoint/2010/main" val="732867857"/>
+              </p:ext>
+            </p:extLst>
           </p:nvPr>
-        </p:nvSpPr>
-        <p:spPr/>
-        <p:txBody>
-          <a:bodyPr/>
+        </p:nvGraphicFramePr>
+        <p:xfrm>
+          <a:off x="838200" y="1690688"/>
+          <a:ext cx="8782481" cy="1956607"/>
+        </p:xfrm>
+        <a:graphic>
+          <a:graphicData uri="http://schemas.openxmlformats.org/drawingml/2006/table">
+            <a:tbl>
+              <a:tblPr>
+                <a:tableStyleId>{5C22544A-7EE6-4342-B048-85BDC9FD1C3A}</a:tableStyleId>
+              </a:tblPr>
+              <a:tblGrid>
+                <a:gridCol w="2429002">
+                  <a:extLst>
+                    <a:ext uri="{9D8B030D-6E8A-4147-A177-3AD203B41FA5}">
+                      <a16:colId xmlns:a16="http://schemas.microsoft.com/office/drawing/2014/main" val="2157829008"/>
+                    </a:ext>
+                  </a:extLst>
+                </a:gridCol>
+                <a:gridCol w="3236024">
+                  <a:extLst>
+                    <a:ext uri="{9D8B030D-6E8A-4147-A177-3AD203B41FA5}">
+                      <a16:colId xmlns:a16="http://schemas.microsoft.com/office/drawing/2014/main" val="1532412348"/>
+                    </a:ext>
+                  </a:extLst>
+                </a:gridCol>
+                <a:gridCol w="3117455">
+                  <a:extLst>
+                    <a:ext uri="{9D8B030D-6E8A-4147-A177-3AD203B41FA5}">
+                      <a16:colId xmlns:a16="http://schemas.microsoft.com/office/drawing/2014/main" val="3369087889"/>
+                    </a:ext>
+                  </a:extLst>
+                </a:gridCol>
+              </a:tblGrid>
+              <a:tr h="316057">
+                <a:tc>
+                  <a:txBody>
+                    <a:bodyPr/>
+                    <a:lstStyle/>
+                    <a:p>
+                      <a:r>
+                        <a:rPr lang="it-IT" b="1" dirty="0"/>
+                        <a:t>Agente</a:t>
+                      </a:r>
+                    </a:p>
+                  </a:txBody>
+                  <a:tcPr>
+                    <a:lnL w="12700" cap="flat" cmpd="sng" algn="ctr">
+                      <a:solidFill>
+                        <a:schemeClr val="tx1"/>
+                      </a:solidFill>
+                      <a:prstDash val="solid"/>
+                      <a:round/>
+                      <a:headEnd type="none" w="med" len="med"/>
+                      <a:tailEnd type="none" w="med" len="med"/>
+                    </a:lnL>
+                    <a:lnR w="12700" cap="flat" cmpd="sng" algn="ctr">
+                      <a:solidFill>
+                        <a:schemeClr val="tx1"/>
+                      </a:solidFill>
+                      <a:prstDash val="solid"/>
+                      <a:round/>
+                      <a:headEnd type="none" w="med" len="med"/>
+                      <a:tailEnd type="none" w="med" len="med"/>
+                    </a:lnR>
+                    <a:lnT w="12700" cap="flat" cmpd="sng" algn="ctr">
+                      <a:solidFill>
+                        <a:schemeClr val="tx1"/>
+                      </a:solidFill>
+                      <a:prstDash val="solid"/>
+                      <a:round/>
+                      <a:headEnd type="none" w="med" len="med"/>
+                      <a:tailEnd type="none" w="med" len="med"/>
+                    </a:lnT>
+                    <a:lnB w="12700" cap="flat" cmpd="sng" algn="ctr">
+                      <a:solidFill>
+                        <a:schemeClr val="tx1"/>
+                      </a:solidFill>
+                      <a:prstDash val="solid"/>
+                      <a:round/>
+                      <a:headEnd type="none" w="med" len="med"/>
+                      <a:tailEnd type="none" w="med" len="med"/>
+                    </a:lnB>
+                    <a:lnTlToBr w="12700" cmpd="sng">
+                      <a:noFill/>
+                      <a:prstDash val="solid"/>
+                    </a:lnTlToBr>
+                    <a:lnBlToTr w="12700" cmpd="sng">
+                      <a:noFill/>
+                      <a:prstDash val="solid"/>
+                    </a:lnBlToTr>
+                    <a:solidFill>
+                      <a:schemeClr val="bg1"/>
+                    </a:solidFill>
+                  </a:tcPr>
+                </a:tc>
+                <a:tc>
+                  <a:txBody>
+                    <a:bodyPr/>
+                    <a:lstStyle/>
+                    <a:p>
+                      <a:r>
+                        <a:rPr lang="it-IT" b="1" dirty="0"/>
+                        <a:t>Modello primario</a:t>
+                      </a:r>
+                    </a:p>
+                  </a:txBody>
+                  <a:tcPr>
+                    <a:lnL w="12700" cap="flat" cmpd="sng" algn="ctr">
+                      <a:solidFill>
+                        <a:schemeClr val="tx1"/>
+                      </a:solidFill>
+                      <a:prstDash val="solid"/>
+                      <a:round/>
+                      <a:headEnd type="none" w="med" len="med"/>
+                      <a:tailEnd type="none" w="med" len="med"/>
+                    </a:lnL>
+                    <a:lnR w="12700" cap="flat" cmpd="sng" algn="ctr">
+                      <a:solidFill>
+                        <a:schemeClr val="tx1"/>
+                      </a:solidFill>
+                      <a:prstDash val="solid"/>
+                      <a:round/>
+                      <a:headEnd type="none" w="med" len="med"/>
+                      <a:tailEnd type="none" w="med" len="med"/>
+                    </a:lnR>
+                    <a:lnT w="12700" cap="flat" cmpd="sng" algn="ctr">
+                      <a:solidFill>
+                        <a:schemeClr val="tx1"/>
+                      </a:solidFill>
+                      <a:prstDash val="solid"/>
+                      <a:round/>
+                      <a:headEnd type="none" w="med" len="med"/>
+                      <a:tailEnd type="none" w="med" len="med"/>
+                    </a:lnT>
+                    <a:lnB w="12700" cap="flat" cmpd="sng" algn="ctr">
+                      <a:solidFill>
+                        <a:schemeClr val="tx1"/>
+                      </a:solidFill>
+                      <a:prstDash val="solid"/>
+                      <a:round/>
+                      <a:headEnd type="none" w="med" len="med"/>
+                      <a:tailEnd type="none" w="med" len="med"/>
+                    </a:lnB>
+                    <a:lnTlToBr w="12700" cmpd="sng">
+                      <a:noFill/>
+                      <a:prstDash val="solid"/>
+                    </a:lnTlToBr>
+                    <a:lnBlToTr w="12700" cmpd="sng">
+                      <a:noFill/>
+                      <a:prstDash val="solid"/>
+                    </a:lnBlToTr>
+                    <a:solidFill>
+                      <a:schemeClr val="bg1"/>
+                    </a:solidFill>
+                  </a:tcPr>
+                </a:tc>
+                <a:tc>
+                  <a:txBody>
+                    <a:bodyPr/>
+                    <a:lstStyle/>
+                    <a:p>
+                      <a:r>
+                        <a:rPr lang="it-IT" b="1" dirty="0"/>
+                        <a:t>Modello di Fallback</a:t>
+                      </a:r>
+                    </a:p>
+                  </a:txBody>
+                  <a:tcPr>
+                    <a:lnL w="12700" cap="flat" cmpd="sng" algn="ctr">
+                      <a:solidFill>
+                        <a:schemeClr val="tx1"/>
+                      </a:solidFill>
+                      <a:prstDash val="solid"/>
+                      <a:round/>
+                      <a:headEnd type="none" w="med" len="med"/>
+                      <a:tailEnd type="none" w="med" len="med"/>
+                    </a:lnL>
+                    <a:lnR w="12700" cap="flat" cmpd="sng" algn="ctr">
+                      <a:solidFill>
+                        <a:schemeClr val="tx1"/>
+                      </a:solidFill>
+                      <a:prstDash val="solid"/>
+                      <a:round/>
+                      <a:headEnd type="none" w="med" len="med"/>
+                      <a:tailEnd type="none" w="med" len="med"/>
+                    </a:lnR>
+                    <a:lnT w="12700" cap="flat" cmpd="sng" algn="ctr">
+                      <a:solidFill>
+                        <a:schemeClr val="tx1"/>
+                      </a:solidFill>
+                      <a:prstDash val="solid"/>
+                      <a:round/>
+                      <a:headEnd type="none" w="med" len="med"/>
+                      <a:tailEnd type="none" w="med" len="med"/>
+                    </a:lnT>
+                    <a:lnB w="12700" cap="flat" cmpd="sng" algn="ctr">
+                      <a:solidFill>
+                        <a:schemeClr val="tx1"/>
+                      </a:solidFill>
+                      <a:prstDash val="solid"/>
+                      <a:round/>
+                      <a:headEnd type="none" w="med" len="med"/>
+                      <a:tailEnd type="none" w="med" len="med"/>
+                    </a:lnB>
+                    <a:lnTlToBr w="12700" cmpd="sng">
+                      <a:noFill/>
+                      <a:prstDash val="solid"/>
+                    </a:lnTlToBr>
+                    <a:lnBlToTr w="12700" cmpd="sng">
+                      <a:noFill/>
+                      <a:prstDash val="solid"/>
+                    </a:lnBlToTr>
+                    <a:solidFill>
+                      <a:schemeClr val="bg1"/>
+                    </a:solidFill>
+                  </a:tcPr>
+                </a:tc>
+                <a:extLst>
+                  <a:ext uri="{0D108BD9-81ED-4DB2-BD59-A6C34878D82A}">
+                    <a16:rowId xmlns:a16="http://schemas.microsoft.com/office/drawing/2014/main" val="901448017"/>
+                  </a:ext>
+                </a:extLst>
+              </a:tr>
+              <a:tr h="484649">
+                <a:tc>
+                  <a:txBody>
+                    <a:bodyPr/>
+                    <a:lstStyle/>
+                    <a:p>
+                      <a:pPr algn="l"/>
+                      <a:r>
+                        <a:rPr lang="it-IT" dirty="0"/>
+                        <a:t>Coordinator</a:t>
+                      </a:r>
+                    </a:p>
+                  </a:txBody>
+                  <a:tcPr>
+                    <a:lnL w="12700" cap="flat" cmpd="sng" algn="ctr">
+                      <a:solidFill>
+                        <a:schemeClr val="tx1"/>
+                      </a:solidFill>
+                      <a:prstDash val="solid"/>
+                      <a:round/>
+                      <a:headEnd type="none" w="med" len="med"/>
+                      <a:tailEnd type="none" w="med" len="med"/>
+                    </a:lnL>
+                    <a:lnR w="12700" cap="flat" cmpd="sng" algn="ctr">
+                      <a:solidFill>
+                        <a:schemeClr val="tx1"/>
+                      </a:solidFill>
+                      <a:prstDash val="solid"/>
+                      <a:round/>
+                      <a:headEnd type="none" w="med" len="med"/>
+                      <a:tailEnd type="none" w="med" len="med"/>
+                    </a:lnR>
+                    <a:lnT w="12700" cap="flat" cmpd="sng" algn="ctr">
+                      <a:solidFill>
+                        <a:schemeClr val="tx1"/>
+                      </a:solidFill>
+                      <a:prstDash val="solid"/>
+                      <a:round/>
+                      <a:headEnd type="none" w="med" len="med"/>
+                      <a:tailEnd type="none" w="med" len="med"/>
+                    </a:lnT>
+                    <a:lnB w="12700" cap="flat" cmpd="sng" algn="ctr">
+                      <a:solidFill>
+                        <a:schemeClr val="tx1"/>
+                      </a:solidFill>
+                      <a:prstDash val="solid"/>
+                      <a:round/>
+                      <a:headEnd type="none" w="med" len="med"/>
+                      <a:tailEnd type="none" w="med" len="med"/>
+                    </a:lnB>
+                    <a:lnTlToBr w="12700" cmpd="sng">
+                      <a:noFill/>
+                      <a:prstDash val="solid"/>
+                    </a:lnTlToBr>
+                    <a:lnBlToTr w="12700" cmpd="sng">
+                      <a:noFill/>
+                      <a:prstDash val="solid"/>
+                    </a:lnBlToTr>
+                    <a:solidFill>
+                      <a:schemeClr val="bg1"/>
+                    </a:solidFill>
+                  </a:tcPr>
+                </a:tc>
+                <a:tc>
+                  <a:txBody>
+                    <a:bodyPr/>
+                    <a:lstStyle/>
+                    <a:p>
+                      <a:pPr algn="l"/>
+                      <a:r>
+                        <a:rPr lang="it-IT" dirty="0"/>
+                        <a:t>Gemini — gemini-3.5-flash-lite</a:t>
+                      </a:r>
+                    </a:p>
+                  </a:txBody>
+                  <a:tcPr>
+                    <a:lnL w="12700" cap="flat" cmpd="sng" algn="ctr">
+                      <a:solidFill>
+                        <a:schemeClr val="tx1"/>
+                      </a:solidFill>
+                      <a:prstDash val="solid"/>
+                      <a:round/>
+                      <a:headEnd type="none" w="med" len="med"/>
+                      <a:tailEnd type="none" w="med" len="med"/>
+                    </a:lnL>
+                    <a:lnR w="12700" cap="flat" cmpd="sng" algn="ctr">
+                      <a:solidFill>
+                        <a:schemeClr val="tx1"/>
+                      </a:solidFill>
+                      <a:prstDash val="solid"/>
+                      <a:round/>
+                      <a:headEnd type="none" w="med" len="med"/>
+                      <a:tailEnd type="none" w="med" len="med"/>
+                    </a:lnR>
+                    <a:lnT w="12700" cap="flat" cmpd="sng" algn="ctr">
+                      <a:solidFill>
+                        <a:schemeClr val="tx1"/>
+                      </a:solidFill>
+                      <a:prstDash val="solid"/>
+                      <a:round/>
+                      <a:headEnd type="none" w="med" len="med"/>
+                      <a:tailEnd type="none" w="med" len="med"/>
+                    </a:lnT>
+                    <a:lnB w="12700" cap="flat" cmpd="sng" algn="ctr">
+                      <a:solidFill>
+                        <a:schemeClr val="tx1"/>
+                      </a:solidFill>
+                      <a:prstDash val="solid"/>
+                      <a:round/>
+                      <a:headEnd type="none" w="med" len="med"/>
+                      <a:tailEnd type="none" w="med" len="med"/>
+                    </a:lnB>
+                    <a:lnTlToBr w="12700" cmpd="sng">
+                      <a:noFill/>
+                      <a:prstDash val="solid"/>
+                    </a:lnTlToBr>
+                    <a:lnBlToTr w="12700" cmpd="sng">
+                      <a:noFill/>
+                      <a:prstDash val="solid"/>
+                    </a:lnBlToTr>
+                    <a:solidFill>
+                      <a:schemeClr val="bg1"/>
+                    </a:solidFill>
+                  </a:tcPr>
+                </a:tc>
+                <a:tc>
+                  <a:txBody>
+                    <a:bodyPr/>
+                    <a:lstStyle/>
+                    <a:p>
+                      <a:pPr algn="l"/>
+                      <a:r>
+                        <a:rPr lang="it-IT" dirty="0"/>
+                        <a:t>Groq qwen3.8-27b</a:t>
+                      </a:r>
+                    </a:p>
+                  </a:txBody>
+                  <a:tcPr>
+                    <a:lnL w="12700" cap="flat" cmpd="sng" algn="ctr">
+                      <a:solidFill>
+                        <a:schemeClr val="tx1"/>
+                      </a:solidFill>
+                      <a:prstDash val="solid"/>
+                      <a:round/>
+                      <a:headEnd type="none" w="med" len="med"/>
+                      <a:tailEnd type="none" w="med" len="med"/>
+                    </a:lnL>
+                    <a:lnR w="12700" cap="flat" cmpd="sng" algn="ctr">
+                      <a:solidFill>
+                        <a:schemeClr val="tx1"/>
+                      </a:solidFill>
+                      <a:prstDash val="solid"/>
+                      <a:round/>
+                      <a:headEnd type="none" w="med" len="med"/>
+                      <a:tailEnd type="none" w="med" len="med"/>
+                    </a:lnR>
+                    <a:lnT w="12700" cap="flat" cmpd="sng" algn="ctr">
+                      <a:solidFill>
+                        <a:schemeClr val="tx1"/>
+                      </a:solidFill>
+                      <a:prstDash val="solid"/>
+                      <a:round/>
+                      <a:headEnd type="none" w="med" len="med"/>
+                      <a:tailEnd type="none" w="med" len="med"/>
+                    </a:lnT>
+                    <a:lnB w="12700" cap="flat" cmpd="sng" algn="ctr">
+                      <a:solidFill>
+                        <a:schemeClr val="tx1"/>
+                      </a:solidFill>
+                      <a:prstDash val="solid"/>
+                      <a:round/>
+                      <a:headEnd type="none" w="med" len="med"/>
+                      <a:tailEnd type="none" w="med" len="med"/>
+                    </a:lnB>
+                    <a:lnTlToBr w="12700" cmpd="sng">
+                      <a:noFill/>
+                      <a:prstDash val="solid"/>
+                    </a:lnTlToBr>
+                    <a:lnBlToTr w="12700" cmpd="sng">
+                      <a:noFill/>
+                      <a:prstDash val="solid"/>
+                    </a:lnBlToTr>
+                    <a:solidFill>
+                      <a:schemeClr val="bg1"/>
+                    </a:solidFill>
+                  </a:tcPr>
+                </a:tc>
+                <a:extLst>
+                  <a:ext uri="{0D108BD9-81ED-4DB2-BD59-A6C34878D82A}">
+                    <a16:rowId xmlns:a16="http://schemas.microsoft.com/office/drawing/2014/main" val="3380264843"/>
+                  </a:ext>
+                </a:extLst>
+              </a:tr>
+              <a:tr h="553099">
+                <a:tc>
+                  <a:txBody>
+                    <a:bodyPr/>
+                    <a:lstStyle/>
+                    <a:p>
+                      <a:pPr algn="l"/>
+                      <a:r>
+                        <a:rPr lang="it-IT" dirty="0"/>
+                        <a:t>Graph Query Agent</a:t>
+                      </a:r>
+                    </a:p>
+                  </a:txBody>
+                  <a:tcPr>
+                    <a:lnL w="12700" cap="flat" cmpd="sng" algn="ctr">
+                      <a:solidFill>
+                        <a:schemeClr val="tx1"/>
+                      </a:solidFill>
+                      <a:prstDash val="solid"/>
+                      <a:round/>
+                      <a:headEnd type="none" w="med" len="med"/>
+                      <a:tailEnd type="none" w="med" len="med"/>
+                    </a:lnL>
+                    <a:lnR w="12700" cap="flat" cmpd="sng" algn="ctr">
+                      <a:solidFill>
+                        <a:schemeClr val="tx1"/>
+                      </a:solidFill>
+                      <a:prstDash val="solid"/>
+                      <a:round/>
+                      <a:headEnd type="none" w="med" len="med"/>
+                      <a:tailEnd type="none" w="med" len="med"/>
+                    </a:lnR>
+                    <a:lnT w="12700" cap="flat" cmpd="sng" algn="ctr">
+                      <a:solidFill>
+                        <a:schemeClr val="tx1"/>
+                      </a:solidFill>
+                      <a:prstDash val="solid"/>
+                      <a:round/>
+                      <a:headEnd type="none" w="med" len="med"/>
+                      <a:tailEnd type="none" w="med" len="med"/>
+                    </a:lnT>
+                    <a:lnB w="12700" cap="flat" cmpd="sng" algn="ctr">
+                      <a:solidFill>
+                        <a:schemeClr val="tx1"/>
+                      </a:solidFill>
+                      <a:prstDash val="solid"/>
+                      <a:round/>
+                      <a:headEnd type="none" w="med" len="med"/>
+                      <a:tailEnd type="none" w="med" len="med"/>
+                    </a:lnB>
+                    <a:lnTlToBr w="12700" cmpd="sng">
+                      <a:noFill/>
+                      <a:prstDash val="solid"/>
+                    </a:lnTlToBr>
+                    <a:lnBlToTr w="12700" cmpd="sng">
+                      <a:noFill/>
+                      <a:prstDash val="solid"/>
+                    </a:lnBlToTr>
+                    <a:solidFill>
+                      <a:schemeClr val="bg1"/>
+                    </a:solidFill>
+                  </a:tcPr>
+                </a:tc>
+                <a:tc>
+                  <a:txBody>
+                    <a:bodyPr/>
+                    <a:lstStyle/>
+                    <a:p>
+                      <a:pPr marL="0" marR="0" lvl="0" indent="0" algn="l" defTabSz="914400" rtl="0" eaLnBrk="1" fontAlgn="auto" latinLnBrk="0" hangingPunct="1">
+                        <a:lnSpc>
+                          <a:spcPct val="100000"/>
+                        </a:lnSpc>
+                        <a:spcBef>
+                          <a:spcPts val="0"/>
+                        </a:spcBef>
+                        <a:spcAft>
+                          <a:spcPts val="0"/>
+                        </a:spcAft>
+                        <a:buClrTx/>
+                        <a:buSzTx/>
+                        <a:buFontTx/>
+                        <a:buNone/>
+                        <a:tabLst/>
+                        <a:defRPr/>
+                      </a:pPr>
+                      <a:r>
+                        <a:rPr lang="it-IT" dirty="0"/>
+                        <a:t>Gemini — gemini-3.5-flash-lite</a:t>
+                      </a:r>
+                    </a:p>
+                  </a:txBody>
+                  <a:tcPr>
+                    <a:lnL w="12700" cap="flat" cmpd="sng" algn="ctr">
+                      <a:solidFill>
+                        <a:schemeClr val="tx1"/>
+                      </a:solidFill>
+                      <a:prstDash val="solid"/>
+                      <a:round/>
+                      <a:headEnd type="none" w="med" len="med"/>
+                      <a:tailEnd type="none" w="med" len="med"/>
+                    </a:lnL>
+                    <a:lnR w="12700" cap="flat" cmpd="sng" algn="ctr">
+                      <a:solidFill>
+                        <a:schemeClr val="tx1"/>
+                      </a:solidFill>
+                      <a:prstDash val="solid"/>
+                      <a:round/>
+                      <a:headEnd type="none" w="med" len="med"/>
+                      <a:tailEnd type="none" w="med" len="med"/>
+                    </a:lnR>
+                    <a:lnT w="12700" cap="flat" cmpd="sng" algn="ctr">
+                      <a:solidFill>
+                        <a:schemeClr val="tx1"/>
+                      </a:solidFill>
+                      <a:prstDash val="solid"/>
+                      <a:round/>
+                      <a:headEnd type="none" w="med" len="med"/>
+                      <a:tailEnd type="none" w="med" len="med"/>
+                    </a:lnT>
+                    <a:lnB w="12700" cap="flat" cmpd="sng" algn="ctr">
+                      <a:solidFill>
+                        <a:schemeClr val="tx1"/>
+                      </a:solidFill>
+                      <a:prstDash val="solid"/>
+                      <a:round/>
+                      <a:headEnd type="none" w="med" len="med"/>
+                      <a:tailEnd type="none" w="med" len="med"/>
+                    </a:lnB>
+                    <a:lnTlToBr w="12700" cmpd="sng">
+                      <a:noFill/>
+                      <a:prstDash val="solid"/>
+                    </a:lnTlToBr>
+                    <a:lnBlToTr w="12700" cmpd="sng">
+                      <a:noFill/>
+                      <a:prstDash val="solid"/>
+                    </a:lnBlToTr>
+                    <a:solidFill>
+                      <a:schemeClr val="bg1"/>
+                    </a:solidFill>
+                  </a:tcPr>
+                </a:tc>
+                <a:tc>
+                  <a:txBody>
+                    <a:bodyPr/>
+                    <a:lstStyle/>
+                    <a:p>
+                      <a:pPr algn="l"/>
+                      <a:r>
+                        <a:rPr lang="it-IT" dirty="0"/>
+                        <a:t>Groq qwen3.8-27b</a:t>
+                      </a:r>
+                    </a:p>
+                  </a:txBody>
+                  <a:tcPr>
+                    <a:lnL w="12700" cap="flat" cmpd="sng" algn="ctr">
+                      <a:solidFill>
+                        <a:schemeClr val="tx1"/>
+                      </a:solidFill>
+                      <a:prstDash val="solid"/>
+                      <a:round/>
+                      <a:headEnd type="none" w="med" len="med"/>
+                      <a:tailEnd type="none" w="med" len="med"/>
+                    </a:lnL>
+                    <a:lnR w="12700" cap="flat" cmpd="sng" algn="ctr">
+                      <a:solidFill>
+                        <a:schemeClr val="tx1"/>
+                      </a:solidFill>
+                      <a:prstDash val="solid"/>
+                      <a:round/>
+                      <a:headEnd type="none" w="med" len="med"/>
+                      <a:tailEnd type="none" w="med" len="med"/>
+                    </a:lnR>
+                    <a:lnT w="12700" cap="flat" cmpd="sng" algn="ctr">
+                      <a:solidFill>
+                        <a:schemeClr val="tx1"/>
+                      </a:solidFill>
+                      <a:prstDash val="solid"/>
+                      <a:round/>
+                      <a:headEnd type="none" w="med" len="med"/>
+                      <a:tailEnd type="none" w="med" len="med"/>
+                    </a:lnT>
+                    <a:lnB w="12700" cap="flat" cmpd="sng" algn="ctr">
+                      <a:solidFill>
+                        <a:schemeClr val="tx1"/>
+                      </a:solidFill>
+                      <a:prstDash val="solid"/>
+                      <a:round/>
+                      <a:headEnd type="none" w="med" len="med"/>
+                      <a:tailEnd type="none" w="med" len="med"/>
+                    </a:lnB>
+                    <a:lnTlToBr w="12700" cmpd="sng">
+                      <a:noFill/>
+                      <a:prstDash val="solid"/>
+                    </a:lnTlToBr>
+                    <a:lnBlToTr w="12700" cmpd="sng">
+                      <a:noFill/>
+                      <a:prstDash val="solid"/>
+                    </a:lnBlToTr>
+                    <a:solidFill>
+                      <a:schemeClr val="bg1"/>
+                    </a:solidFill>
+                  </a:tcPr>
+                </a:tc>
+                <a:extLst>
+                  <a:ext uri="{0D108BD9-81ED-4DB2-BD59-A6C34878D82A}">
+                    <a16:rowId xmlns:a16="http://schemas.microsoft.com/office/drawing/2014/main" val="529237727"/>
+                  </a:ext>
+                </a:extLst>
+              </a:tr>
+              <a:tr h="553099">
+                <a:tc>
+                  <a:txBody>
+                    <a:bodyPr/>
+                    <a:lstStyle/>
+                    <a:p>
+                      <a:pPr algn="l"/>
+                      <a:r>
+                        <a:rPr lang="it-IT" dirty="0"/>
+                        <a:t>Semantic Query Agent</a:t>
+                      </a:r>
+                    </a:p>
+                  </a:txBody>
+                  <a:tcPr>
+                    <a:lnL w="12700" cap="flat" cmpd="sng" algn="ctr">
+                      <a:solidFill>
+                        <a:schemeClr val="tx1"/>
+                      </a:solidFill>
+                      <a:prstDash val="solid"/>
+                      <a:round/>
+                      <a:headEnd type="none" w="med" len="med"/>
+                      <a:tailEnd type="none" w="med" len="med"/>
+                    </a:lnL>
+                    <a:lnR w="12700" cap="flat" cmpd="sng" algn="ctr">
+                      <a:solidFill>
+                        <a:schemeClr val="tx1"/>
+                      </a:solidFill>
+                      <a:prstDash val="solid"/>
+                      <a:round/>
+                      <a:headEnd type="none" w="med" len="med"/>
+                      <a:tailEnd type="none" w="med" len="med"/>
+                    </a:lnR>
+                    <a:lnT w="12700" cap="flat" cmpd="sng" algn="ctr">
+                      <a:solidFill>
+                        <a:schemeClr val="tx1"/>
+                      </a:solidFill>
+                      <a:prstDash val="solid"/>
+                      <a:round/>
+                      <a:headEnd type="none" w="med" len="med"/>
+                      <a:tailEnd type="none" w="med" len="med"/>
+                    </a:lnT>
+                    <a:lnB w="12700" cap="flat" cmpd="sng" algn="ctr">
+                      <a:solidFill>
+                        <a:schemeClr val="tx1"/>
+                      </a:solidFill>
+                      <a:prstDash val="solid"/>
+                      <a:round/>
+                      <a:headEnd type="none" w="med" len="med"/>
+                      <a:tailEnd type="none" w="med" len="med"/>
+                    </a:lnB>
+                    <a:lnTlToBr w="12700" cmpd="sng">
+                      <a:noFill/>
+                      <a:prstDash val="solid"/>
+                    </a:lnTlToBr>
+                    <a:lnBlToTr w="12700" cmpd="sng">
+                      <a:noFill/>
+                      <a:prstDash val="solid"/>
+                    </a:lnBlToTr>
+                    <a:solidFill>
+                      <a:schemeClr val="bg1"/>
+                    </a:solidFill>
+                  </a:tcPr>
+                </a:tc>
+                <a:tc>
+                  <a:txBody>
+                    <a:bodyPr/>
+                    <a:lstStyle/>
+                    <a:p>
+                      <a:pPr marL="0" marR="0" lvl="0" indent="0" algn="l" defTabSz="914400" rtl="0" eaLnBrk="1" fontAlgn="auto" latinLnBrk="0" hangingPunct="1">
+                        <a:lnSpc>
+                          <a:spcPct val="100000"/>
+                        </a:lnSpc>
+                        <a:spcBef>
+                          <a:spcPts val="0"/>
+                        </a:spcBef>
+                        <a:spcAft>
+                          <a:spcPts val="0"/>
+                        </a:spcAft>
+                        <a:buClrTx/>
+                        <a:buSzTx/>
+                        <a:buFontTx/>
+                        <a:buNone/>
+                        <a:tabLst/>
+                        <a:defRPr/>
+                      </a:pPr>
+                      <a:r>
+                        <a:rPr lang="it-IT" dirty="0"/>
+                        <a:t>Gemini — gemini-3.5-flash-lite</a:t>
+                      </a:r>
+                    </a:p>
+                  </a:txBody>
+                  <a:tcPr>
+                    <a:lnL w="12700" cap="flat" cmpd="sng" algn="ctr">
+                      <a:solidFill>
+                        <a:schemeClr val="tx1"/>
+                      </a:solidFill>
+                      <a:prstDash val="solid"/>
+                      <a:round/>
+                      <a:headEnd type="none" w="med" len="med"/>
+                      <a:tailEnd type="none" w="med" len="med"/>
+                    </a:lnL>
+                    <a:lnR w="12700" cap="flat" cmpd="sng" algn="ctr">
+                      <a:solidFill>
+                        <a:schemeClr val="tx1"/>
+                      </a:solidFill>
+                      <a:prstDash val="solid"/>
+                      <a:round/>
+                      <a:headEnd type="none" w="med" len="med"/>
+                      <a:tailEnd type="none" w="med" len="med"/>
+                    </a:lnR>
+                    <a:lnT w="12700" cap="flat" cmpd="sng" algn="ctr">
+                      <a:solidFill>
+                        <a:schemeClr val="tx1"/>
+                      </a:solidFill>
+                      <a:prstDash val="solid"/>
+                      <a:round/>
+                      <a:headEnd type="none" w="med" len="med"/>
+                      <a:tailEnd type="none" w="med" len="med"/>
+                    </a:lnT>
+                    <a:lnB w="12700" cap="flat" cmpd="sng" algn="ctr">
+                      <a:solidFill>
+                        <a:schemeClr val="tx1"/>
+                      </a:solidFill>
+                      <a:prstDash val="solid"/>
+                      <a:round/>
+                      <a:headEnd type="none" w="med" len="med"/>
+                      <a:tailEnd type="none" w="med" len="med"/>
+                    </a:lnB>
+                    <a:lnTlToBr w="12700" cmpd="sng">
+                      <a:noFill/>
+                      <a:prstDash val="solid"/>
+                    </a:lnTlToBr>
+                    <a:lnBlToTr w="12700" cmpd="sng">
+                      <a:noFill/>
+                      <a:prstDash val="solid"/>
+                    </a:lnBlToTr>
+                    <a:solidFill>
+                      <a:schemeClr val="bg1"/>
+                    </a:solidFill>
+                  </a:tcPr>
+                </a:tc>
+                <a:tc>
+                  <a:txBody>
+                    <a:bodyPr/>
+                    <a:lstStyle/>
+                    <a:p>
+                      <a:pPr algn="l"/>
+                      <a:r>
+                        <a:rPr lang="it-IT" dirty="0"/>
+                        <a:t>Groq qwen3.8-27b</a:t>
+                      </a:r>
+                    </a:p>
+                  </a:txBody>
+                  <a:tcPr>
+                    <a:lnL w="12700" cap="flat" cmpd="sng" algn="ctr">
+                      <a:solidFill>
+                        <a:schemeClr val="tx1"/>
+                      </a:solidFill>
+                      <a:prstDash val="solid"/>
+                      <a:round/>
+                      <a:headEnd type="none" w="med" len="med"/>
+                      <a:tailEnd type="none" w="med" len="med"/>
+                    </a:lnL>
+                    <a:lnR w="12700" cap="flat" cmpd="sng" algn="ctr">
+                      <a:solidFill>
+                        <a:schemeClr val="tx1"/>
+                      </a:solidFill>
+                      <a:prstDash val="solid"/>
+                      <a:round/>
+                      <a:headEnd type="none" w="med" len="med"/>
+                      <a:tailEnd type="none" w="med" len="med"/>
+                    </a:lnR>
+                    <a:lnT w="12700" cap="flat" cmpd="sng" algn="ctr">
+                      <a:solidFill>
+                        <a:schemeClr val="tx1"/>
+                      </a:solidFill>
+                      <a:prstDash val="solid"/>
+                      <a:round/>
+                      <a:headEnd type="none" w="med" len="med"/>
+                      <a:tailEnd type="none" w="med" len="med"/>
+                    </a:lnT>
+                    <a:lnB w="12700" cap="flat" cmpd="sng" algn="ctr">
+                      <a:solidFill>
+                        <a:schemeClr val="tx1"/>
+                      </a:solidFill>
+                      <a:prstDash val="solid"/>
+                      <a:round/>
+                      <a:headEnd type="none" w="med" len="med"/>
+                      <a:tailEnd type="none" w="med" len="med"/>
+                    </a:lnB>
+                    <a:lnTlToBr w="12700" cmpd="sng">
+                      <a:noFill/>
+                      <a:prstDash val="solid"/>
+                    </a:lnTlToBr>
+                    <a:lnBlToTr w="12700" cmpd="sng">
+                      <a:noFill/>
+                      <a:prstDash val="solid"/>
+                    </a:lnBlToTr>
+                    <a:solidFill>
+                      <a:schemeClr val="bg1"/>
+                    </a:solidFill>
+                  </a:tcPr>
+                </a:tc>
+                <a:extLst>
+                  <a:ext uri="{0D108BD9-81ED-4DB2-BD59-A6C34878D82A}">
+                    <a16:rowId xmlns:a16="http://schemas.microsoft.com/office/drawing/2014/main" val="4049080122"/>
+                  </a:ext>
+                </a:extLst>
+              </a:tr>
+            </a:tbl>
+          </a:graphicData>
+        </a:graphic>
+      </p:graphicFrame>
+      <p:sp>
+        <p:nvSpPr>
+          <p:cNvPr id="8" name="CasellaDiTesto 7">
+            <a:extLst>
+              <a:ext uri="{FF2B5EF4-FFF2-40B4-BE49-F238E27FC236}">
+                <a16:creationId xmlns:a16="http://schemas.microsoft.com/office/drawing/2014/main" id="{E8B132C0-E0F0-8BFF-D306-E8953DC82FFF}"/>
+              </a:ext>
+            </a:extLst>
+          </p:cNvPr>
+          <p:cNvSpPr txBox="1"/>
+          <p:nvPr/>
+        </p:nvSpPr>
+        <p:spPr>
+          <a:xfrm>
+            <a:off x="838200" y="3957195"/>
+            <a:ext cx="9996055" cy="2031325"/>
+          </a:xfrm>
+          <a:prstGeom prst="rect">
+            <a:avLst/>
+          </a:prstGeom>
+          <a:noFill/>
+        </p:spPr>
+        <p:txBody>
+          <a:bodyPr wrap="square">
+            <a:spAutoFit/>
+          </a:bodyPr>
           <a:lstStyle/>
           <a:p>
             <a:r>
               <a:rPr lang="it-IT" dirty="0"/>
-              <a:t>Fare notebook che legge csv con dati tracing</a:t>
+              <a:t>In caso di mancata risposta di un modello LLM a causa di:</a:t>
+            </a:r>
+          </a:p>
+          <a:p>
+            <a:pPr marL="285750" indent="-285750">
+              <a:buFontTx/>
+              <a:buChar char="-"/>
+            </a:pPr>
+            <a:r>
+              <a:rPr lang="it-IT" dirty="0"/>
+              <a:t>indisponibilità del servizio (es. errore 503 "high demand")</a:t>
+            </a:r>
+          </a:p>
+          <a:p>
+            <a:pPr marL="285750" indent="-285750">
+              <a:buFontTx/>
+              <a:buChar char="-"/>
+            </a:pPr>
+            <a:r>
+              <a:rPr lang="it-IT" dirty="0"/>
+              <a:t>rate limit del free tier esaurito (429)</a:t>
+            </a:r>
+          </a:p>
+          <a:p>
+            <a:pPr marL="285750" indent="-285750">
+              <a:buFontTx/>
+              <a:buChar char="-"/>
+            </a:pPr>
+            <a:r>
+              <a:rPr lang="it-IT" dirty="0"/>
+              <a:t>timeout della richiesta</a:t>
+            </a:r>
+          </a:p>
+          <a:p>
+            <a:r>
+              <a:rPr lang="it-IT" dirty="0"/>
+              <a:t>il sistema esegue prima 3 tentativi (15s → 30s → 60s); se anche questi falliscono, passa automaticamente a un modello di fallback, garantendo continuità del servizio senza intervento manuale.</a:t>
             </a:r>
           </a:p>
         </p:txBody>
@@ -3995,7 +6772,7 @@
     </p:spTree>
     <p:extLst>
       <p:ext uri="{BB962C8B-B14F-4D97-AF65-F5344CB8AC3E}">
-        <p14:creationId xmlns:p14="http://schemas.microsoft.com/office/powerpoint/2010/main" val="1293278231"/>
+        <p14:creationId xmlns:p14="http://schemas.microsoft.com/office/powerpoint/2010/main" val="1727977134"/>
       </p:ext>
     </p:extLst>
   </p:cSld>
@@ -4006,6 +6783,316 @@
 </file>
 
 <file path=ppt/slides/slide13.xml><?xml version="1.0" encoding="utf-8"?>
+<p:sld xmlns:a="http://schemas.openxmlformats.org/drawingml/2006/main" xmlns:r="http://schemas.openxmlformats.org/officeDocument/2006/relationships" xmlns:p="http://schemas.openxmlformats.org/presentationml/2006/main">
+  <p:cSld>
+    <p:spTree>
+      <p:nvGrpSpPr>
+        <p:cNvPr id="1" name="">
+          <a:extLst>
+            <a:ext uri="{FF2B5EF4-FFF2-40B4-BE49-F238E27FC236}">
+              <a16:creationId xmlns:a16="http://schemas.microsoft.com/office/drawing/2014/main" id="{08A9CF28-1461-741E-0D64-190CCBD25E11}"/>
+            </a:ext>
+          </a:extLst>
+        </p:cNvPr>
+        <p:cNvGrpSpPr/>
+        <p:nvPr/>
+      </p:nvGrpSpPr>
+      <p:grpSpPr>
+        <a:xfrm>
+          <a:off x="0" y="0"/>
+          <a:ext cx="0" cy="0"/>
+          <a:chOff x="0" y="0"/>
+          <a:chExt cx="0" cy="0"/>
+        </a:xfrm>
+      </p:grpSpPr>
+      <p:sp>
+        <p:nvSpPr>
+          <p:cNvPr id="2" name="Titolo 1">
+            <a:extLst>
+              <a:ext uri="{FF2B5EF4-FFF2-40B4-BE49-F238E27FC236}">
+                <a16:creationId xmlns:a16="http://schemas.microsoft.com/office/drawing/2014/main" id="{2C56CB9C-B434-9151-DF44-880CF3284C70}"/>
+              </a:ext>
+            </a:extLst>
+          </p:cNvPr>
+          <p:cNvSpPr>
+            <a:spLocks noGrp="1"/>
+          </p:cNvSpPr>
+          <p:nvPr>
+            <p:ph type="title"/>
+          </p:nvPr>
+        </p:nvSpPr>
+        <p:spPr/>
+        <p:txBody>
+          <a:bodyPr/>
+          <a:lstStyle/>
+          <a:p>
+            <a:r>
+              <a:rPr lang="it-IT" dirty="0"/>
+              <a:t>Evaluation</a:t>
+            </a:r>
+          </a:p>
+        </p:txBody>
+      </p:sp>
+      <p:sp>
+        <p:nvSpPr>
+          <p:cNvPr id="8" name="CasellaDiTesto 7">
+            <a:extLst>
+              <a:ext uri="{FF2B5EF4-FFF2-40B4-BE49-F238E27FC236}">
+                <a16:creationId xmlns:a16="http://schemas.microsoft.com/office/drawing/2014/main" id="{763B068F-A1FA-0216-7825-4B09CB950D1A}"/>
+              </a:ext>
+            </a:extLst>
+          </p:cNvPr>
+          <p:cNvSpPr txBox="1"/>
+          <p:nvPr/>
+        </p:nvSpPr>
+        <p:spPr>
+          <a:xfrm>
+            <a:off x="551329" y="1690688"/>
+            <a:ext cx="9996055" cy="2308324"/>
+          </a:xfrm>
+          <a:prstGeom prst="rect">
+            <a:avLst/>
+          </a:prstGeom>
+          <a:noFill/>
+        </p:spPr>
+        <p:txBody>
+          <a:bodyPr wrap="square">
+            <a:spAutoFit/>
+          </a:bodyPr>
+          <a:lstStyle/>
+          <a:p>
+            <a:r>
+              <a:rPr lang="it-IT" dirty="0"/>
+              <a:t>Utilizzo come post-hook di AgentAsJudgeEval di agno (LLM as a Judge), che gira in background con gemini-3.5-flash-lite (stesso modello degli agenti) e assegna un punteggio numerico da 1 a 10, basandosi principalmente su:</a:t>
+            </a:r>
+          </a:p>
+          <a:p>
+            <a:pPr marL="285750" indent="-285750">
+              <a:buFontTx/>
+              <a:buChar char="-"/>
+            </a:pPr>
+            <a:r>
+              <a:rPr lang="it-IT" dirty="0"/>
+              <a:t>Risposta in italiano e pertinente</a:t>
+            </a:r>
+          </a:p>
+          <a:p>
+            <a:pPr marL="285750" indent="-285750">
+              <a:buFontTx/>
+              <a:buChar char="-"/>
+            </a:pPr>
+            <a:r>
+              <a:rPr lang="it-IT" dirty="0"/>
+              <a:t>Nessun dato/nome/numero inventato rispetto a Neo4j/ChromaDB</a:t>
+            </a:r>
+          </a:p>
+          <a:p>
+            <a:pPr marL="285750" indent="-285750">
+              <a:buFontTx/>
+              <a:buChar char="-"/>
+            </a:pPr>
+            <a:r>
+              <a:rPr lang="it-IT" dirty="0"/>
+              <a:t>Nessuna sezione meta ("come abbiamo ottenuto questi dati")</a:t>
+            </a:r>
+          </a:p>
+          <a:p>
+            <a:pPr marL="285750" indent="-285750">
+              <a:buFontTx/>
+              <a:buChar char="-"/>
+            </a:pPr>
+            <a:r>
+              <a:rPr lang="it-IT" dirty="0"/>
+              <a:t>Nei pitch creativi: cast giustificato da collaborazioni reali, non arbitrario.</a:t>
+            </a:r>
+          </a:p>
+          <a:p>
+            <a:endParaRPr lang="it-IT" dirty="0"/>
+          </a:p>
+        </p:txBody>
+      </p:sp>
+      <p:sp>
+        <p:nvSpPr>
+          <p:cNvPr id="3" name="CasellaDiTesto 2">
+            <a:extLst>
+              <a:ext uri="{FF2B5EF4-FFF2-40B4-BE49-F238E27FC236}">
+                <a16:creationId xmlns:a16="http://schemas.microsoft.com/office/drawing/2014/main" id="{843F058A-2305-0965-BE41-39F8DF13FA51}"/>
+              </a:ext>
+            </a:extLst>
+          </p:cNvPr>
+          <p:cNvSpPr txBox="1"/>
+          <p:nvPr/>
+        </p:nvSpPr>
+        <p:spPr>
+          <a:xfrm>
+            <a:off x="4374776" y="4661647"/>
+            <a:ext cx="1574470" cy="369332"/>
+          </a:xfrm>
+          <a:prstGeom prst="rect">
+            <a:avLst/>
+          </a:prstGeom>
+          <a:noFill/>
+        </p:spPr>
+        <p:txBody>
+          <a:bodyPr wrap="none" rtlCol="0">
+            <a:spAutoFit/>
+          </a:bodyPr>
+          <a:lstStyle/>
+          <a:p>
+            <a:r>
+              <a:rPr lang="it-IT" dirty="0"/>
+              <a:t>GRAFICI EVAL</a:t>
+            </a:r>
+          </a:p>
+        </p:txBody>
+      </p:sp>
+    </p:spTree>
+    <p:extLst>
+      <p:ext uri="{BB962C8B-B14F-4D97-AF65-F5344CB8AC3E}">
+        <p14:creationId xmlns:p14="http://schemas.microsoft.com/office/powerpoint/2010/main" val="1010017531"/>
+      </p:ext>
+    </p:extLst>
+  </p:cSld>
+  <p:clrMapOvr>
+    <a:masterClrMapping/>
+  </p:clrMapOvr>
+</p:sld>
+</file>
+
+<file path=ppt/slides/slide14.xml><?xml version="1.0" encoding="utf-8"?>
+<p:sld xmlns:a="http://schemas.openxmlformats.org/drawingml/2006/main" xmlns:r="http://schemas.openxmlformats.org/officeDocument/2006/relationships" xmlns:p="http://schemas.openxmlformats.org/presentationml/2006/main">
+  <p:cSld>
+    <p:spTree>
+      <p:nvGrpSpPr>
+        <p:cNvPr id="1" name="">
+          <a:extLst>
+            <a:ext uri="{FF2B5EF4-FFF2-40B4-BE49-F238E27FC236}">
+              <a16:creationId xmlns:a16="http://schemas.microsoft.com/office/drawing/2014/main" id="{354CF079-4072-E0E4-3C26-ECC1C9557190}"/>
+            </a:ext>
+          </a:extLst>
+        </p:cNvPr>
+        <p:cNvGrpSpPr/>
+        <p:nvPr/>
+      </p:nvGrpSpPr>
+      <p:grpSpPr>
+        <a:xfrm>
+          <a:off x="0" y="0"/>
+          <a:ext cx="0" cy="0"/>
+          <a:chOff x="0" y="0"/>
+          <a:chExt cx="0" cy="0"/>
+        </a:xfrm>
+      </p:grpSpPr>
+      <p:sp>
+        <p:nvSpPr>
+          <p:cNvPr id="2" name="Titolo 1">
+            <a:extLst>
+              <a:ext uri="{FF2B5EF4-FFF2-40B4-BE49-F238E27FC236}">
+                <a16:creationId xmlns:a16="http://schemas.microsoft.com/office/drawing/2014/main" id="{EEBE1A42-E019-02EA-987D-843C22E86F9B}"/>
+              </a:ext>
+            </a:extLst>
+          </p:cNvPr>
+          <p:cNvSpPr>
+            <a:spLocks noGrp="1"/>
+          </p:cNvSpPr>
+          <p:nvPr>
+            <p:ph type="title"/>
+          </p:nvPr>
+        </p:nvSpPr>
+        <p:spPr/>
+        <p:txBody>
+          <a:bodyPr/>
+          <a:lstStyle/>
+          <a:p>
+            <a:r>
+              <a:rPr lang="it-IT" dirty="0"/>
+              <a:t>Possibile evoluzione Evaluation</a:t>
+            </a:r>
+          </a:p>
+        </p:txBody>
+      </p:sp>
+      <p:sp>
+        <p:nvSpPr>
+          <p:cNvPr id="8" name="CasellaDiTesto 7">
+            <a:extLst>
+              <a:ext uri="{FF2B5EF4-FFF2-40B4-BE49-F238E27FC236}">
+                <a16:creationId xmlns:a16="http://schemas.microsoft.com/office/drawing/2014/main" id="{4D6B64D8-580A-0920-9192-A3A3C08CECE8}"/>
+              </a:ext>
+            </a:extLst>
+          </p:cNvPr>
+          <p:cNvSpPr txBox="1"/>
+          <p:nvPr/>
+        </p:nvSpPr>
+        <p:spPr>
+          <a:xfrm>
+            <a:off x="551329" y="1690688"/>
+            <a:ext cx="9996055" cy="3970318"/>
+          </a:xfrm>
+          <a:prstGeom prst="rect">
+            <a:avLst/>
+          </a:prstGeom>
+          <a:noFill/>
+        </p:spPr>
+        <p:txBody>
+          <a:bodyPr wrap="square">
+            <a:spAutoFit/>
+          </a:bodyPr>
+          <a:lstStyle/>
+          <a:p>
+            <a:r>
+              <a:rPr lang="it-IT" dirty="0"/>
+              <a:t>Il giudice attuale (LLM-as-Judge) valuta solo il testo di domanda e risposta, senza accesso al contesto effettivamente recuperato dai tool — un limite reale, verificato empiricamente (caso "Snatch": un titolo citato come risultato di ricerca semantica ma mai restituito da ChromaDB, non rilevato dal giudice).</a:t>
+            </a:r>
+          </a:p>
+          <a:p>
+            <a:endParaRPr lang="it-IT" dirty="0"/>
+          </a:p>
+          <a:p>
+            <a:r>
+              <a:rPr lang="it-IT" dirty="0"/>
+              <a:t>Un'estensione naturale sarebbe l'integrazione di </a:t>
+            </a:r>
+            <a:r>
+              <a:rPr lang="it-IT" b="1" dirty="0"/>
+              <a:t>RAGAS</a:t>
+            </a:r>
+            <a:r>
+              <a:rPr lang="it-IT" dirty="0"/>
+              <a:t> (Retrieval-Augmented Generation Assessment), in particolare la metrica di </a:t>
+            </a:r>
+            <a:r>
+              <a:rPr lang="it-IT" b="1" dirty="0"/>
+              <a:t>Faithfulness</a:t>
+            </a:r>
+            <a:r>
+              <a:rPr lang="it-IT" dirty="0"/>
+              <a:t>: confronta ogni affermazione della risposta con il contesto realmente recuperato, individuando esattamente questo tipo di allucinazione che il giudice attuale non può cogliere.</a:t>
+            </a:r>
+          </a:p>
+          <a:p>
+            <a:endParaRPr lang="it-IT" dirty="0"/>
+          </a:p>
+          <a:p>
+            <a:r>
+              <a:rPr lang="it-IT" dirty="0"/>
+              <a:t>Il compromesso: richiede ulteriori chiamate LLM per ogni valutazione (pressione aggiuntiva sulla quota free-tier, già un collo di bottiglia del sistema), ed è pensata per pipeline RAG su base vettoriale — si adatterebbe naturalmente al Semantic Agent, mentre andrebbe adattata per valutare i risultati strutturali del Graph Agent (Cypher/Neo4j).</a:t>
+            </a:r>
+          </a:p>
+        </p:txBody>
+      </p:sp>
+    </p:spTree>
+    <p:extLst>
+      <p:ext uri="{BB962C8B-B14F-4D97-AF65-F5344CB8AC3E}">
+        <p14:creationId xmlns:p14="http://schemas.microsoft.com/office/powerpoint/2010/main" val="1959142791"/>
+      </p:ext>
+    </p:extLst>
+  </p:cSld>
+  <p:clrMapOvr>
+    <a:masterClrMapping/>
+  </p:clrMapOvr>
+</p:sld>
+</file>
+
+<file path=ppt/slides/slide15.xml><?xml version="1.0" encoding="utf-8"?>
 <p:sld xmlns:a="http://schemas.openxmlformats.org/drawingml/2006/main" xmlns:r="http://schemas.openxmlformats.org/officeDocument/2006/relationships" xmlns:p="http://schemas.openxmlformats.org/presentationml/2006/main">
   <p:cSld>
     <p:spTree>
@@ -4235,7 +7322,7 @@
         </p:nvSpPr>
         <p:spPr>
           <a:xfrm>
-            <a:off x="7411243" y="618985"/>
+            <a:off x="8781705" y="607901"/>
             <a:ext cx="2195665" cy="481452"/>
           </a:xfrm>
           <a:prstGeom prst="roundRect">
@@ -4299,7 +7386,7 @@
         </p:nvSpPr>
         <p:spPr>
           <a:xfrm>
-            <a:off x="7411243" y="3805682"/>
+            <a:off x="8781705" y="3709437"/>
             <a:ext cx="2195665" cy="475469"/>
           </a:xfrm>
           <a:prstGeom prst="roundRect">
@@ -4363,7 +7450,7 @@
         </p:nvSpPr>
         <p:spPr>
           <a:xfrm>
-            <a:off x="7411243" y="2144860"/>
+            <a:off x="8781705" y="2133776"/>
             <a:ext cx="2195665" cy="475469"/>
           </a:xfrm>
           <a:prstGeom prst="roundRect">
@@ -4427,7 +7514,7 @@
         </p:nvSpPr>
         <p:spPr>
           <a:xfrm>
-            <a:off x="7721045" y="1847520"/>
+            <a:off x="9091507" y="1836436"/>
             <a:ext cx="1538370" cy="307777"/>
           </a:xfrm>
           <a:prstGeom prst="rect">
@@ -4462,7 +7549,7 @@
         </p:nvSpPr>
         <p:spPr>
           <a:xfrm>
-            <a:off x="8026962" y="311207"/>
+            <a:off x="9397424" y="300123"/>
             <a:ext cx="926536" cy="307777"/>
           </a:xfrm>
           <a:prstGeom prst="rect">
@@ -4497,7 +7584,7 @@
         </p:nvSpPr>
         <p:spPr>
           <a:xfrm>
-            <a:off x="8048350" y="3490234"/>
+            <a:off x="9418812" y="3393989"/>
             <a:ext cx="926536" cy="307777"/>
           </a:xfrm>
           <a:prstGeom prst="rect">
@@ -4534,7 +7621,7 @@
         </p:nvCxnSpPr>
         <p:spPr>
           <a:xfrm flipV="1">
-            <a:off x="8504263" y="1164195"/>
+            <a:off x="9874725" y="1067950"/>
             <a:ext cx="0" cy="686886"/>
           </a:xfrm>
           <a:prstGeom prst="straightConnector1">
@@ -4579,7 +7666,7 @@
         </p:nvCxnSpPr>
         <p:spPr>
           <a:xfrm flipH="1" flipV="1">
-            <a:off x="8482875" y="2768574"/>
+            <a:off x="9853337" y="2672329"/>
             <a:ext cx="7355" cy="721660"/>
           </a:xfrm>
           <a:prstGeom prst="straightConnector1">
@@ -4672,59 +7759,6 @@
           </a:p>
         </p:txBody>
       </p:sp>
-      <p:sp>
-        <p:nvSpPr>
-          <p:cNvPr id="4" name="Rettangolo 3">
-            <a:extLst>
-              <a:ext uri="{FF2B5EF4-FFF2-40B4-BE49-F238E27FC236}">
-                <a16:creationId xmlns:a16="http://schemas.microsoft.com/office/drawing/2014/main" id="{08B545B1-802E-F7C3-B5D6-1791FBC0AE5F}"/>
-              </a:ext>
-            </a:extLst>
-          </p:cNvPr>
-          <p:cNvSpPr/>
-          <p:nvPr/>
-        </p:nvSpPr>
-        <p:spPr>
-          <a:xfrm>
-            <a:off x="7064477" y="176981"/>
-            <a:ext cx="2875936" cy="4441788"/>
-          </a:xfrm>
-          <a:prstGeom prst="rect">
-            <a:avLst/>
-          </a:prstGeom>
-          <a:noFill/>
-          <a:ln>
-            <a:solidFill>
-              <a:schemeClr val="tx1"/>
-            </a:solidFill>
-            <a:prstDash val="dash"/>
-          </a:ln>
-        </p:spPr>
-        <p:style>
-          <a:lnRef idx="2">
-            <a:schemeClr val="accent1">
-              <a:shade val="15000"/>
-            </a:schemeClr>
-          </a:lnRef>
-          <a:fillRef idx="1">
-            <a:schemeClr val="accent1"/>
-          </a:fillRef>
-          <a:effectRef idx="0">
-            <a:schemeClr val="accent1"/>
-          </a:effectRef>
-          <a:fontRef idx="minor">
-            <a:schemeClr val="lt1"/>
-          </a:fontRef>
-        </p:style>
-        <p:txBody>
-          <a:bodyPr rtlCol="0" anchor="ctr"/>
-          <a:lstStyle/>
-          <a:p>
-            <a:pPr algn="ctr"/>
-            <a:endParaRPr lang="it-IT"/>
-          </a:p>
-        </p:txBody>
-      </p:sp>
       <p:cxnSp>
         <p:nvCxnSpPr>
           <p:cNvPr id="12" name="Connettore a gomito 11">
@@ -4735,17 +7769,17 @@
             </a:extLst>
           </p:cNvPr>
           <p:cNvCxnSpPr>
-            <a:stCxn id="3" idx="3"/>
+            <a:cxnSpLocks/>
             <a:endCxn id="17" idx="1"/>
           </p:cNvCxnSpPr>
           <p:nvPr/>
         </p:nvCxnSpPr>
         <p:spPr>
-          <a:xfrm flipV="1">
-            <a:off x="5443388" y="2382595"/>
-            <a:ext cx="1967855" cy="2272007"/>
+          <a:xfrm rot="5400000" flipH="1" flipV="1">
+            <a:off x="6800476" y="2673374"/>
+            <a:ext cx="2283091" cy="1679367"/>
           </a:xfrm>
-          <a:prstGeom prst="bentConnector3">
+          <a:prstGeom prst="bentConnector2">
             <a:avLst/>
           </a:prstGeom>
           <a:ln>
@@ -4784,7 +7818,7 @@
         </p:nvSpPr>
         <p:spPr>
           <a:xfrm>
-            <a:off x="7392397" y="5395160"/>
+            <a:off x="8762859" y="5298915"/>
             <a:ext cx="2195665" cy="475469"/>
           </a:xfrm>
           <a:prstGeom prst="roundRect">
@@ -4843,6 +7877,7 @@
             </a:extLst>
           </p:cNvPr>
           <p:cNvCxnSpPr>
+            <a:cxnSpLocks/>
             <a:stCxn id="3" idx="3"/>
             <a:endCxn id="14" idx="1"/>
           </p:cNvCxnSpPr>
@@ -4851,11 +7886,11 @@
         <p:spPr>
           <a:xfrm>
             <a:off x="5443388" y="4654602"/>
-            <a:ext cx="1949009" cy="978293"/>
+            <a:ext cx="3319471" cy="882048"/>
           </a:xfrm>
           <a:prstGeom prst="bentConnector3">
             <a:avLst>
-              <a:gd name="adj1" fmla="val 50382"/>
+              <a:gd name="adj1" fmla="val 50000"/>
             </a:avLst>
           </a:prstGeom>
           <a:ln>
@@ -4929,8 +7964,8 @@
         </p:nvSpPr>
         <p:spPr>
           <a:xfrm>
-            <a:off x="6857811" y="5900927"/>
-            <a:ext cx="4191374" cy="523220"/>
+            <a:off x="8228273" y="5804682"/>
+            <a:ext cx="3317404" cy="523220"/>
           </a:xfrm>
           <a:prstGeom prst="rect">
             <a:avLst/>
@@ -4958,12 +7993,83 @@
           </a:p>
         </p:txBody>
       </p:sp>
-      <p:sp>
-        <p:nvSpPr>
-          <p:cNvPr id="31" name="CasellaDiTesto 30">
-            <a:extLst>
-              <a:ext uri="{FF2B5EF4-FFF2-40B4-BE49-F238E27FC236}">
-                <a16:creationId xmlns:a16="http://schemas.microsoft.com/office/drawing/2014/main" id="{26605343-B72D-BEDE-EB70-48DF9418AE30}"/>
+    </p:spTree>
+    <p:extLst>
+      <p:ext uri="{BB962C8B-B14F-4D97-AF65-F5344CB8AC3E}">
+        <p14:creationId xmlns:p14="http://schemas.microsoft.com/office/powerpoint/2010/main" val="677498370"/>
+      </p:ext>
+    </p:extLst>
+  </p:cSld>
+  <p:clrMapOvr>
+    <a:masterClrMapping/>
+  </p:clrMapOvr>
+</p:sld>
+</file>
+
+<file path=ppt/slides/slide16.xml><?xml version="1.0" encoding="utf-8"?>
+<p:sld xmlns:a="http://schemas.openxmlformats.org/drawingml/2006/main" xmlns:r="http://schemas.openxmlformats.org/officeDocument/2006/relationships" xmlns:p="http://schemas.openxmlformats.org/presentationml/2006/main">
+  <p:cSld>
+    <p:spTree>
+      <p:nvGrpSpPr>
+        <p:cNvPr id="1" name="">
+          <a:extLst>
+            <a:ext uri="{FF2B5EF4-FFF2-40B4-BE49-F238E27FC236}">
+              <a16:creationId xmlns:a16="http://schemas.microsoft.com/office/drawing/2014/main" id="{2B4CAC2B-CE96-E1A0-1C30-F6D370D24B63}"/>
+            </a:ext>
+          </a:extLst>
+        </p:cNvPr>
+        <p:cNvGrpSpPr/>
+        <p:nvPr/>
+      </p:nvGrpSpPr>
+      <p:grpSpPr>
+        <a:xfrm>
+          <a:off x="0" y="0"/>
+          <a:ext cx="0" cy="0"/>
+          <a:chOff x="0" y="0"/>
+          <a:chExt cx="0" cy="0"/>
+        </a:xfrm>
+      </p:grpSpPr>
+      <p:sp>
+        <p:nvSpPr>
+          <p:cNvPr id="2" name="Titolo 1">
+            <a:extLst>
+              <a:ext uri="{FF2B5EF4-FFF2-40B4-BE49-F238E27FC236}">
+                <a16:creationId xmlns:a16="http://schemas.microsoft.com/office/drawing/2014/main" id="{736B55FE-1411-19A2-C9E5-66518AED6FF3}"/>
+              </a:ext>
+            </a:extLst>
+          </p:cNvPr>
+          <p:cNvSpPr>
+            <a:spLocks noGrp="1"/>
+          </p:cNvSpPr>
+          <p:nvPr>
+            <p:ph type="title"/>
+          </p:nvPr>
+        </p:nvSpPr>
+        <p:spPr>
+          <a:xfrm>
+            <a:off x="838199" y="365126"/>
+            <a:ext cx="8616044" cy="1131166"/>
+          </a:xfrm>
+        </p:spPr>
+        <p:txBody>
+          <a:bodyPr>
+            <a:normAutofit/>
+          </a:bodyPr>
+          <a:lstStyle/>
+          <a:p>
+            <a:r>
+              <a:rPr lang="it-IT" dirty="0"/>
+              <a:t>Possibile evoluzione Architettura</a:t>
+            </a:r>
+          </a:p>
+        </p:txBody>
+      </p:sp>
+      <p:sp>
+        <p:nvSpPr>
+          <p:cNvPr id="4" name="CasellaDiTesto 3">
+            <a:extLst>
+              <a:ext uri="{FF2B5EF4-FFF2-40B4-BE49-F238E27FC236}">
+                <a16:creationId xmlns:a16="http://schemas.microsoft.com/office/drawing/2014/main" id="{E4BE5479-72EF-3B74-2373-C2D6F05435AC}"/>
               </a:ext>
             </a:extLst>
           </p:cNvPr>
@@ -4972,8 +8078,8 @@
         </p:nvSpPr>
         <p:spPr>
           <a:xfrm>
-            <a:off x="9960749" y="126076"/>
-            <a:ext cx="1884298" cy="307777"/>
+            <a:off x="457325" y="4120219"/>
+            <a:ext cx="761747" cy="369332"/>
           </a:xfrm>
           <a:prstGeom prst="rect">
             <a:avLst/>
@@ -4987,16 +8093,485 @@
           <a:lstStyle/>
           <a:p>
             <a:r>
-              <a:rPr lang="it-IT" sz="1400" dirty="0"/>
-              <a:t>PARTE GIA’ PRESENTE</a:t>
-            </a:r>
-          </a:p>
-        </p:txBody>
-      </p:sp>
+              <a:rPr lang="it-IT" b="1" dirty="0"/>
+              <a:t>USER</a:t>
+            </a:r>
+          </a:p>
+        </p:txBody>
+      </p:sp>
+      <p:sp>
+        <p:nvSpPr>
+          <p:cNvPr id="5" name="CasellaDiTesto 4">
+            <a:extLst>
+              <a:ext uri="{FF2B5EF4-FFF2-40B4-BE49-F238E27FC236}">
+                <a16:creationId xmlns:a16="http://schemas.microsoft.com/office/drawing/2014/main" id="{5E1E59D0-9630-D941-5C01-2295AA3C73CC}"/>
+              </a:ext>
+            </a:extLst>
+          </p:cNvPr>
+          <p:cNvSpPr txBox="1"/>
+          <p:nvPr/>
+        </p:nvSpPr>
+        <p:spPr>
+          <a:xfrm>
+            <a:off x="1777173" y="3935187"/>
+            <a:ext cx="1079463" cy="369332"/>
+          </a:xfrm>
+          <a:prstGeom prst="rect">
+            <a:avLst/>
+          </a:prstGeom>
+          <a:noFill/>
+        </p:spPr>
+        <p:txBody>
+          <a:bodyPr wrap="none" rtlCol="0">
+            <a:spAutoFit/>
+          </a:bodyPr>
+          <a:lstStyle/>
+          <a:p>
+            <a:r>
+              <a:rPr lang="it-IT" dirty="0"/>
+              <a:t>PROMPT</a:t>
+            </a:r>
+          </a:p>
+        </p:txBody>
+      </p:sp>
+      <p:cxnSp>
+        <p:nvCxnSpPr>
+          <p:cNvPr id="7" name="Connettore dritto 6">
+            <a:extLst>
+              <a:ext uri="{FF2B5EF4-FFF2-40B4-BE49-F238E27FC236}">
+                <a16:creationId xmlns:a16="http://schemas.microsoft.com/office/drawing/2014/main" id="{1D3780C1-00B3-24B5-0CE8-905976361E95}"/>
+              </a:ext>
+            </a:extLst>
+          </p:cNvPr>
+          <p:cNvCxnSpPr>
+            <a:cxnSpLocks/>
+            <a:stCxn id="4" idx="3"/>
+            <a:endCxn id="11" idx="1"/>
+          </p:cNvCxnSpPr>
+          <p:nvPr/>
+        </p:nvCxnSpPr>
+        <p:spPr>
+          <a:xfrm>
+            <a:off x="1219072" y="4304885"/>
+            <a:ext cx="2488717" cy="1"/>
+          </a:xfrm>
+          <a:prstGeom prst="line">
+            <a:avLst/>
+          </a:prstGeom>
+          <a:ln>
+            <a:solidFill>
+              <a:schemeClr val="tx1"/>
+            </a:solidFill>
+            <a:tailEnd type="triangle"/>
+          </a:ln>
+        </p:spPr>
+        <p:style>
+          <a:lnRef idx="2">
+            <a:schemeClr val="accent1"/>
+          </a:lnRef>
+          <a:fillRef idx="0">
+            <a:schemeClr val="accent1"/>
+          </a:fillRef>
+          <a:effectRef idx="1">
+            <a:schemeClr val="accent1"/>
+          </a:effectRef>
+          <a:fontRef idx="minor">
+            <a:schemeClr val="tx1"/>
+          </a:fontRef>
+        </p:style>
+      </p:cxnSp>
+      <p:sp>
+        <p:nvSpPr>
+          <p:cNvPr id="8" name="Rettangolo con angoli arrotondati 7">
+            <a:extLst>
+              <a:ext uri="{FF2B5EF4-FFF2-40B4-BE49-F238E27FC236}">
+                <a16:creationId xmlns:a16="http://schemas.microsoft.com/office/drawing/2014/main" id="{BFA238F3-7043-F269-1839-2C9C146E2754}"/>
+              </a:ext>
+            </a:extLst>
+          </p:cNvPr>
+          <p:cNvSpPr/>
+          <p:nvPr/>
+        </p:nvSpPr>
+        <p:spPr>
+          <a:xfrm>
+            <a:off x="3693756" y="2219706"/>
+            <a:ext cx="2195665" cy="623449"/>
+          </a:xfrm>
+          <a:prstGeom prst="roundRect">
+            <a:avLst/>
+          </a:prstGeom>
+          <a:solidFill>
+            <a:schemeClr val="accent3">
+              <a:lumMod val="20000"/>
+              <a:lumOff val="80000"/>
+            </a:schemeClr>
+          </a:solidFill>
+          <a:ln w="12700">
+            <a:solidFill>
+              <a:schemeClr val="tx1"/>
+            </a:solidFill>
+          </a:ln>
+        </p:spPr>
+        <p:style>
+          <a:lnRef idx="2">
+            <a:schemeClr val="accent1">
+              <a:shade val="15000"/>
+            </a:schemeClr>
+          </a:lnRef>
+          <a:fillRef idx="1">
+            <a:schemeClr val="accent1"/>
+          </a:fillRef>
+          <a:effectRef idx="0">
+            <a:schemeClr val="accent1"/>
+          </a:effectRef>
+          <a:fontRef idx="minor">
+            <a:schemeClr val="lt1"/>
+          </a:fontRef>
+        </p:style>
+        <p:txBody>
+          <a:bodyPr rtlCol="0" anchor="ctr"/>
+          <a:lstStyle/>
+          <a:p>
+            <a:pPr algn="ctr"/>
+            <a:r>
+              <a:rPr lang="it-IT" b="1" dirty="0">
+                <a:solidFill>
+                  <a:schemeClr val="tx1"/>
+                </a:solidFill>
+              </a:rPr>
+              <a:t>GRAPH QUERY AGENT</a:t>
+            </a:r>
+          </a:p>
+        </p:txBody>
+      </p:sp>
+      <p:sp>
+        <p:nvSpPr>
+          <p:cNvPr id="9" name="Rettangolo con angoli arrotondati 8">
+            <a:extLst>
+              <a:ext uri="{FF2B5EF4-FFF2-40B4-BE49-F238E27FC236}">
+                <a16:creationId xmlns:a16="http://schemas.microsoft.com/office/drawing/2014/main" id="{8E9A61F2-A6D2-C4FE-2F23-B5D077B6E4B1}"/>
+              </a:ext>
+            </a:extLst>
+          </p:cNvPr>
+          <p:cNvSpPr/>
+          <p:nvPr/>
+        </p:nvSpPr>
+        <p:spPr>
+          <a:xfrm>
+            <a:off x="3693756" y="5771069"/>
+            <a:ext cx="2195665" cy="623449"/>
+          </a:xfrm>
+          <a:prstGeom prst="roundRect">
+            <a:avLst/>
+          </a:prstGeom>
+          <a:solidFill>
+            <a:schemeClr val="accent1">
+              <a:lumMod val="20000"/>
+              <a:lumOff val="80000"/>
+            </a:schemeClr>
+          </a:solidFill>
+          <a:ln w="12700">
+            <a:solidFill>
+              <a:schemeClr val="tx1"/>
+            </a:solidFill>
+          </a:ln>
+        </p:spPr>
+        <p:style>
+          <a:lnRef idx="2">
+            <a:schemeClr val="accent1">
+              <a:shade val="15000"/>
+            </a:schemeClr>
+          </a:lnRef>
+          <a:fillRef idx="1">
+            <a:schemeClr val="accent1"/>
+          </a:fillRef>
+          <a:effectRef idx="0">
+            <a:schemeClr val="accent1"/>
+          </a:effectRef>
+          <a:fontRef idx="minor">
+            <a:schemeClr val="lt1"/>
+          </a:fontRef>
+        </p:style>
+        <p:txBody>
+          <a:bodyPr rtlCol="0" anchor="ctr"/>
+          <a:lstStyle/>
+          <a:p>
+            <a:pPr algn="ctr"/>
+            <a:r>
+              <a:rPr lang="it-IT" b="1" dirty="0">
+                <a:solidFill>
+                  <a:schemeClr val="tx1"/>
+                </a:solidFill>
+              </a:rPr>
+              <a:t>SEMANTIC QUERY AGENT</a:t>
+            </a:r>
+          </a:p>
+        </p:txBody>
+      </p:sp>
+      <p:sp>
+        <p:nvSpPr>
+          <p:cNvPr id="11" name="Rettangolo con angoli arrotondati 10">
+            <a:extLst>
+              <a:ext uri="{FF2B5EF4-FFF2-40B4-BE49-F238E27FC236}">
+                <a16:creationId xmlns:a16="http://schemas.microsoft.com/office/drawing/2014/main" id="{BD026D9E-DA5C-ED2E-2AF9-E0CADE9EAE87}"/>
+              </a:ext>
+            </a:extLst>
+          </p:cNvPr>
+          <p:cNvSpPr/>
+          <p:nvPr/>
+        </p:nvSpPr>
+        <p:spPr>
+          <a:xfrm>
+            <a:off x="3707789" y="3993161"/>
+            <a:ext cx="2195665" cy="623449"/>
+          </a:xfrm>
+          <a:prstGeom prst="roundRect">
+            <a:avLst/>
+          </a:prstGeom>
+          <a:solidFill>
+            <a:schemeClr val="accent2">
+              <a:lumMod val="20000"/>
+              <a:lumOff val="80000"/>
+            </a:schemeClr>
+          </a:solidFill>
+          <a:ln w="12700">
+            <a:solidFill>
+              <a:schemeClr val="tx1"/>
+            </a:solidFill>
+          </a:ln>
+        </p:spPr>
+        <p:style>
+          <a:lnRef idx="2">
+            <a:schemeClr val="accent1">
+              <a:shade val="15000"/>
+            </a:schemeClr>
+          </a:lnRef>
+          <a:fillRef idx="1">
+            <a:schemeClr val="accent1"/>
+          </a:fillRef>
+          <a:effectRef idx="0">
+            <a:schemeClr val="accent1"/>
+          </a:effectRef>
+          <a:fontRef idx="minor">
+            <a:schemeClr val="lt1"/>
+          </a:fontRef>
+        </p:style>
+        <p:txBody>
+          <a:bodyPr rtlCol="0" anchor="ctr"/>
+          <a:lstStyle/>
+          <a:p>
+            <a:pPr algn="ctr"/>
+            <a:r>
+              <a:rPr lang="it-IT" b="1" dirty="0">
+                <a:solidFill>
+                  <a:schemeClr val="tx1"/>
+                </a:solidFill>
+              </a:rPr>
+              <a:t>CREATIVE AGENT</a:t>
+            </a:r>
+          </a:p>
+        </p:txBody>
+      </p:sp>
+      <p:sp>
+        <p:nvSpPr>
+          <p:cNvPr id="15" name="CasellaDiTesto 14">
+            <a:extLst>
+              <a:ext uri="{FF2B5EF4-FFF2-40B4-BE49-F238E27FC236}">
+                <a16:creationId xmlns:a16="http://schemas.microsoft.com/office/drawing/2014/main" id="{9CE63282-B9B8-D74F-2BB0-790BC78593E1}"/>
+              </a:ext>
+            </a:extLst>
+          </p:cNvPr>
+          <p:cNvSpPr txBox="1"/>
+          <p:nvPr/>
+        </p:nvSpPr>
+        <p:spPr>
+          <a:xfrm>
+            <a:off x="4017591" y="3695821"/>
+            <a:ext cx="1538370" cy="307777"/>
+          </a:xfrm>
+          <a:prstGeom prst="rect">
+            <a:avLst/>
+          </a:prstGeom>
+          <a:noFill/>
+        </p:spPr>
+        <p:txBody>
+          <a:bodyPr wrap="none" rtlCol="0">
+            <a:spAutoFit/>
+          </a:bodyPr>
+          <a:lstStyle/>
+          <a:p>
+            <a:r>
+              <a:rPr lang="it-IT" sz="1400" b="1" dirty="0"/>
+              <a:t>COORDINATORE</a:t>
+            </a:r>
+          </a:p>
+        </p:txBody>
+      </p:sp>
+      <p:sp>
+        <p:nvSpPr>
+          <p:cNvPr id="20" name="CasellaDiTesto 19">
+            <a:extLst>
+              <a:ext uri="{FF2B5EF4-FFF2-40B4-BE49-F238E27FC236}">
+                <a16:creationId xmlns:a16="http://schemas.microsoft.com/office/drawing/2014/main" id="{E1524376-D7FE-C5DC-E4FE-0B1A056E11D1}"/>
+              </a:ext>
+            </a:extLst>
+          </p:cNvPr>
+          <p:cNvSpPr txBox="1"/>
+          <p:nvPr/>
+        </p:nvSpPr>
+        <p:spPr>
+          <a:xfrm>
+            <a:off x="4309475" y="1911929"/>
+            <a:ext cx="926536" cy="307777"/>
+          </a:xfrm>
+          <a:prstGeom prst="rect">
+            <a:avLst/>
+          </a:prstGeom>
+          <a:noFill/>
+        </p:spPr>
+        <p:txBody>
+          <a:bodyPr wrap="none" rtlCol="0">
+            <a:spAutoFit/>
+          </a:bodyPr>
+          <a:lstStyle/>
+          <a:p>
+            <a:r>
+              <a:rPr lang="it-IT" sz="1400" b="1" dirty="0"/>
+              <a:t>WORKER</a:t>
+            </a:r>
+          </a:p>
+        </p:txBody>
+      </p:sp>
+      <p:sp>
+        <p:nvSpPr>
+          <p:cNvPr id="24" name="CasellaDiTesto 23">
+            <a:extLst>
+              <a:ext uri="{FF2B5EF4-FFF2-40B4-BE49-F238E27FC236}">
+                <a16:creationId xmlns:a16="http://schemas.microsoft.com/office/drawing/2014/main" id="{88154EAA-F942-A6DA-51B5-4B4DE2A04183}"/>
+              </a:ext>
+            </a:extLst>
+          </p:cNvPr>
+          <p:cNvSpPr txBox="1"/>
+          <p:nvPr/>
+        </p:nvSpPr>
+        <p:spPr>
+          <a:xfrm>
+            <a:off x="4330863" y="5455621"/>
+            <a:ext cx="926536" cy="307777"/>
+          </a:xfrm>
+          <a:prstGeom prst="rect">
+            <a:avLst/>
+          </a:prstGeom>
+          <a:noFill/>
+        </p:spPr>
+        <p:txBody>
+          <a:bodyPr wrap="none" rtlCol="0">
+            <a:spAutoFit/>
+          </a:bodyPr>
+          <a:lstStyle/>
+          <a:p>
+            <a:r>
+              <a:rPr lang="it-IT" sz="1400" b="1" dirty="0"/>
+              <a:t>WORKER</a:t>
+            </a:r>
+          </a:p>
+        </p:txBody>
+      </p:sp>
+      <p:cxnSp>
+        <p:nvCxnSpPr>
+          <p:cNvPr id="25" name="Connettore diritto a freccia 24">
+            <a:extLst>
+              <a:ext uri="{FF2B5EF4-FFF2-40B4-BE49-F238E27FC236}">
+                <a16:creationId xmlns:a16="http://schemas.microsoft.com/office/drawing/2014/main" id="{E2EC01AF-C8D7-36D9-F428-44A82E182688}"/>
+              </a:ext>
+            </a:extLst>
+          </p:cNvPr>
+          <p:cNvCxnSpPr>
+            <a:stCxn id="15" idx="0"/>
+          </p:cNvCxnSpPr>
+          <p:nvPr/>
+        </p:nvCxnSpPr>
+        <p:spPr>
+          <a:xfrm flipV="1">
+            <a:off x="4786776" y="3008935"/>
+            <a:ext cx="0" cy="686886"/>
+          </a:xfrm>
+          <a:prstGeom prst="straightConnector1">
+            <a:avLst/>
+          </a:prstGeom>
+          <a:ln>
+            <a:solidFill>
+              <a:schemeClr val="tx1"/>
+            </a:solidFill>
+            <a:headEnd type="triangle"/>
+            <a:tailEnd type="triangle"/>
+          </a:ln>
+        </p:spPr>
+        <p:style>
+          <a:lnRef idx="2">
+            <a:schemeClr val="accent1"/>
+          </a:lnRef>
+          <a:fillRef idx="0">
+            <a:schemeClr val="accent1"/>
+          </a:fillRef>
+          <a:effectRef idx="1">
+            <a:schemeClr val="accent1"/>
+          </a:effectRef>
+          <a:fontRef idx="minor">
+            <a:schemeClr val="tx1"/>
+          </a:fontRef>
+        </p:style>
+      </p:cxnSp>
+      <p:cxnSp>
+        <p:nvCxnSpPr>
+          <p:cNvPr id="26" name="Connettore diritto a freccia 25">
+            <a:extLst>
+              <a:ext uri="{FF2B5EF4-FFF2-40B4-BE49-F238E27FC236}">
+                <a16:creationId xmlns:a16="http://schemas.microsoft.com/office/drawing/2014/main" id="{AD123702-9BDE-1EFE-7349-E5F2D784835C}"/>
+              </a:ext>
+            </a:extLst>
+          </p:cNvPr>
+          <p:cNvCxnSpPr>
+            <a:cxnSpLocks/>
+            <a:stCxn id="24" idx="0"/>
+          </p:cNvCxnSpPr>
+          <p:nvPr/>
+        </p:nvCxnSpPr>
+        <p:spPr>
+          <a:xfrm flipH="1" flipV="1">
+            <a:off x="4786776" y="4733961"/>
+            <a:ext cx="7355" cy="721660"/>
+          </a:xfrm>
+          <a:prstGeom prst="straightConnector1">
+            <a:avLst/>
+          </a:prstGeom>
+          <a:ln>
+            <a:solidFill>
+              <a:schemeClr val="tx1"/>
+            </a:solidFill>
+            <a:headEnd type="triangle"/>
+            <a:tailEnd type="triangle"/>
+          </a:ln>
+        </p:spPr>
+        <p:style>
+          <a:lnRef idx="2">
+            <a:schemeClr val="accent1"/>
+          </a:lnRef>
+          <a:fillRef idx="0">
+            <a:schemeClr val="accent1"/>
+          </a:fillRef>
+          <a:effectRef idx="1">
+            <a:schemeClr val="accent1"/>
+          </a:effectRef>
+          <a:fontRef idx="minor">
+            <a:schemeClr val="tx1"/>
+          </a:fontRef>
+        </p:style>
+      </p:cxnSp>
     </p:spTree>
     <p:extLst>
       <p:ext uri="{BB962C8B-B14F-4D97-AF65-F5344CB8AC3E}">
-        <p14:creationId xmlns:p14="http://schemas.microsoft.com/office/powerpoint/2010/main" val="677498370"/>
+        <p14:creationId xmlns:p14="http://schemas.microsoft.com/office/powerpoint/2010/main" val="1064967964"/>
       </p:ext>
     </p:extLst>
   </p:cSld>
@@ -5824,98 +9399,112 @@
       </p:sp>
       <p:sp>
         <p:nvSpPr>
-          <p:cNvPr id="8" name="Segnaposto contenuto 4">
-            <a:extLst>
-              <a:ext uri="{FF2B5EF4-FFF2-40B4-BE49-F238E27FC236}">
-                <a16:creationId xmlns:a16="http://schemas.microsoft.com/office/drawing/2014/main" id="{C2F14399-B1C5-CF98-D1CE-52E5A565B40A}"/>
-              </a:ext>
-            </a:extLst>
-          </p:cNvPr>
-          <p:cNvSpPr>
-            <a:spLocks noGrp="1"/>
-          </p:cNvSpPr>
-          <p:nvPr>
-            <p:ph idx="1"/>
-          </p:nvPr>
+          <p:cNvPr id="4" name="CasellaDiTesto 3">
+            <a:extLst>
+              <a:ext uri="{FF2B5EF4-FFF2-40B4-BE49-F238E27FC236}">
+                <a16:creationId xmlns:a16="http://schemas.microsoft.com/office/drawing/2014/main" id="{BCCC0560-7EDA-CBE7-6544-589E5557B2A5}"/>
+              </a:ext>
+            </a:extLst>
+          </p:cNvPr>
+          <p:cNvSpPr txBox="1"/>
+          <p:nvPr/>
         </p:nvSpPr>
         <p:spPr>
           <a:xfrm>
-            <a:off x="838200" y="1825625"/>
-            <a:ext cx="10515600" cy="4285615"/>
+            <a:off x="519952" y="1674674"/>
+            <a:ext cx="10833848" cy="3016210"/>
           </a:xfrm>
+          <a:prstGeom prst="rect">
+            <a:avLst/>
+          </a:prstGeom>
+          <a:noFill/>
         </p:spPr>
         <p:txBody>
-          <a:bodyPr>
-            <a:noAutofit/>
+          <a:bodyPr wrap="square">
+            <a:spAutoFit/>
           </a:bodyPr>
           <a:lstStyle/>
           <a:p>
-            <a:pPr>
-              <a:buNone/>
-            </a:pPr>
             <a:r>
               <a:rPr lang="it-IT" sz="2000" dirty="0">
                 <a:solidFill>
                   <a:srgbClr val="000000"/>
                 </a:solidFill>
               </a:rPr>
-              <a:t>Realizzato su più giorni.</a:t>
-            </a:r>
-            <a:endParaRPr lang="it-IT" altLang="it-IT" sz="2000" dirty="0"/>
-          </a:p>
-          <a:p>
-            <a:pPr marL="0" lvl="0" indent="0" eaLnBrk="0" fontAlgn="base" hangingPunct="0">
-              <a:lnSpc>
-                <a:spcPct val="100000"/>
-              </a:lnSpc>
-              <a:spcBef>
-                <a:spcPct val="0"/>
-              </a:spcBef>
-              <a:spcAft>
-                <a:spcPct val="0"/>
-              </a:spcAft>
-              <a:buNone/>
+              <a:t>Ogni film e ogni biografia (attore/regista) diventa un </a:t>
+            </a:r>
+            <a:r>
+              <a:rPr lang="it-IT" sz="2000" u="sng" dirty="0">
+                <a:solidFill>
+                  <a:srgbClr val="000000"/>
+                </a:solidFill>
+              </a:rPr>
+              <a:t>documento unico</a:t>
+            </a:r>
+            <a:r>
+              <a:rPr lang="it-IT" sz="2000" dirty="0">
+                <a:solidFill>
+                  <a:srgbClr val="000000"/>
+                </a:solidFill>
+              </a:rPr>
+              <a:t>, arricchito con metadati testuali (titolo, regista, cast, generi per i film; nome, ruolo, data e luogo di nascita per le biografie) prima di essere embeddato.</a:t>
+            </a:r>
+            <a:endParaRPr lang="it-IT" sz="2000" dirty="0"/>
+          </a:p>
+          <a:p>
+            <a:endParaRPr lang="it-IT" dirty="0"/>
+          </a:p>
+          <a:p>
+            <a:pPr marL="285750" indent="-285750">
+              <a:buFontTx/>
+              <a:buChar char="-"/>
             </a:pPr>
-            <a:endParaRPr lang="it-IT" sz="2000" dirty="0"/>
-          </a:p>
-          <a:p>
-            <a:pPr marL="0" lvl="0" indent="0" eaLnBrk="0" fontAlgn="base" hangingPunct="0">
-              <a:lnSpc>
-                <a:spcPct val="100000"/>
-              </a:lnSpc>
-              <a:spcBef>
-                <a:spcPct val="0"/>
-              </a:spcBef>
-              <a:spcAft>
-                <a:spcPct val="0"/>
-              </a:spcAft>
-              <a:buNone/>
+            <a:r>
+              <a:rPr lang="it-IT" sz="2400" dirty="0"/>
+              <a:t>Modello: </a:t>
+            </a:r>
+            <a:r>
+              <a:rPr lang="it-IT" sz="2400" b="1" dirty="0"/>
+              <a:t>Gemini gemini-embedding-001</a:t>
+            </a:r>
+            <a:r>
+              <a:rPr lang="it-IT" sz="2400" dirty="0"/>
+              <a:t>, dimensione 1536</a:t>
+            </a:r>
+            <a:r>
+              <a:rPr lang="it-IT" dirty="0"/>
+              <a:t>.</a:t>
+            </a:r>
+          </a:p>
+          <a:p>
+            <a:pPr marL="285750" indent="-285750">
+              <a:buFontTx/>
+              <a:buChar char="-"/>
             </a:pPr>
-            <a:endParaRPr lang="it-IT" sz="2000" dirty="0"/>
-          </a:p>
-          <a:p>
-            <a:pPr marL="0" lvl="0" indent="0" eaLnBrk="0" fontAlgn="base" hangingPunct="0">
-              <a:lnSpc>
-                <a:spcPct val="100000"/>
-              </a:lnSpc>
-              <a:spcBef>
-                <a:spcPct val="0"/>
-              </a:spcBef>
-              <a:spcAft>
-                <a:spcPct val="0"/>
-              </a:spcAft>
-              <a:buNone/>
+            <a:r>
+              <a:rPr lang="it-IT" sz="2400" dirty="0"/>
+              <a:t>Nessun chunking</a:t>
+            </a:r>
+          </a:p>
+          <a:p>
+            <a:pPr marL="285750" indent="-285750">
+              <a:buFontTx/>
+              <a:buChar char="-"/>
             </a:pPr>
-            <a:endParaRPr lang="it-IT" altLang="it-IT" sz="2000" dirty="0"/>
-          </a:p>
-          <a:p>
-            <a:pPr>
-              <a:buNone/>
-            </a:pPr>
-            <a:endParaRPr lang="it-IT" sz="2000" dirty="0">
-              <a:solidFill>
-                <a:srgbClr val="000000"/>
-              </a:solidFill>
+            <a:endParaRPr lang="it-IT" sz="2400" dirty="0"/>
+          </a:p>
+          <a:p>
+            <a:r>
+              <a:rPr lang="it-IT" altLang="it-IT" sz="2000" dirty="0">
+                <a:solidFill>
+                  <a:srgbClr val="000000"/>
+                </a:solidFill>
+                <a:latin typeface="Arial" panose="020B0604020202020204" pitchFamily="34" charset="0"/>
+              </a:rPr>
+              <a:t>Ingestion eseguita su più giorni: a causa dei limiti di quota del piano gratuito Gemini (rate limit giornalieri sull'embedding) con checkpoint.</a:t>
+            </a:r>
+            <a:endParaRPr lang="it-IT" altLang="it-IT" sz="2000" dirty="0">
+              <a:latin typeface="Arial" panose="020B0604020202020204" pitchFamily="34" charset="0"/>
             </a:endParaRPr>
           </a:p>
         </p:txBody>

</xml_diff>